<commit_message>
Updated file for demo on December 8
</commit_message>
<xml_diff>
--- a/demo_presentations/A104_Vis_and_Analysis_Presentation.pptx
+++ b/demo_presentations/A104_Vis_and_Analysis_Presentation.pptx
@@ -5,14 +5,16 @@
     <p:sldMasterId id="2147483662" r:id="rId1"/>
   </p:sldMasterIdLst>
   <p:notesMasterIdLst>
-    <p:notesMasterId r:id="rId7"/>
+    <p:notesMasterId r:id="rId9"/>
   </p:notesMasterIdLst>
   <p:sldIdLst>
     <p:sldId id="256" r:id="rId2"/>
     <p:sldId id="257" r:id="rId3"/>
     <p:sldId id="259" r:id="rId4"/>
-    <p:sldId id="260" r:id="rId5"/>
-    <p:sldId id="261" r:id="rId6"/>
+    <p:sldId id="261" r:id="rId5"/>
+    <p:sldId id="262" r:id="rId6"/>
+    <p:sldId id="264" r:id="rId7"/>
+    <p:sldId id="265" r:id="rId8"/>
   </p:sldIdLst>
   <p:sldSz cx="12192000" cy="6858000"/>
   <p:notesSz cx="6858000" cy="9144000"/>
@@ -282,7 +284,8 @@
 <file path=ppt/revisionInfo.xml><?xml version="1.0" encoding="utf-8"?>
 <p1510:revInfo xmlns:a="http://schemas.openxmlformats.org/drawingml/2006/main" xmlns:r="http://schemas.openxmlformats.org/officeDocument/2006/relationships" xmlns:p1510="http://schemas.microsoft.com/office/powerpoint/2015/10/main">
   <p1510:revLst>
-    <p1510:client id="{EC113BB5-92DE-F6DC-4EA1-D00DAA6C4FCA}" v="238" dt="2025-12-01T12:25:03.105"/>
+    <p1510:client id="{6D546167-77AF-D2AC-1A99-E07477C0F94B}" v="4" dt="2025-12-06T15:00:31.992"/>
+    <p1510:client id="{75EF905B-8216-F3C6-2E53-187A9D15709F}" v="228" dt="2025-12-08T13:38:01.308"/>
   </p1510:revLst>
 </p1510:revInfo>
 </file>
@@ -11329,7 +11332,7 @@
             </a:br>
             <a:r>
               <a:rPr lang="en-GB" sz="2200" dirty="0"/>
-              <a:t>Date: 01-12-2025</a:t>
+              <a:t>Date: 08-12-2025</a:t>
             </a:r>
             <a:br>
               <a:rPr lang="en-GB" sz="8000" dirty="0"/>
@@ -11762,7 +11765,7 @@
                 <a:cs typeface="Calibri"/>
                 <a:sym typeface="Calibri"/>
               </a:rPr>
-              <a:t>“Is there a difference in the median stress level between doctors and software engineers in the 27 to 59 age” </a:t>
+              <a:t>“Is there a difference in the median stress level between doctors and software engineers in the 27 to 59 age group?” </a:t>
             </a:r>
             <a:r>
               <a:rPr lang="en-GB" sz="2200" baseline="30000" dirty="0">
@@ -13347,30 +13350,6 @@
           </a:p>
         </p:txBody>
       </p:sp>
-      <p:pic>
-        <p:nvPicPr>
-          <p:cNvPr id="5" name="Picture 4" descr="doc_hist.png"/>
-          <p:cNvPicPr>
-            <a:picLocks noChangeAspect="1"/>
-          </p:cNvPicPr>
-          <p:nvPr/>
-        </p:nvPicPr>
-        <p:blipFill>
-          <a:blip r:embed="rId2"/>
-          <a:stretch>
-            <a:fillRect/>
-          </a:stretch>
-        </p:blipFill>
-        <p:spPr>
-          <a:xfrm>
-            <a:off x="2798074" y="1711922"/>
-            <a:ext cx="6042260" cy="4974079"/>
-          </a:xfrm>
-          <a:prstGeom prst="rect">
-            <a:avLst/>
-          </a:prstGeom>
-        </p:spPr>
-      </p:pic>
       <p:sp>
         <p:nvSpPr>
           <p:cNvPr id="8" name="Title 1">
@@ -13387,8 +13366,8 @@
         </p:nvSpPr>
         <p:spPr>
           <a:xfrm>
-            <a:off x="760216" y="794172"/>
-            <a:ext cx="9572196" cy="615059"/>
+            <a:off x="760216" y="783734"/>
+            <a:ext cx="9572196" cy="740319"/>
           </a:xfrm>
           <a:prstGeom prst="rect">
             <a:avLst/>
@@ -13652,7 +13631,7 @@
           <a:p>
             <a:r>
               <a:rPr lang="en-US" sz="2800" dirty="0"/>
-              <a:t>Graph 1: Histogram for stress level among doctors</a:t>
+              <a:t>Graph 1: Histogram for stress level by Occupation</a:t>
             </a:r>
           </a:p>
         </p:txBody>
@@ -13700,75 +13679,15 @@
           </a:p>
         </p:txBody>
       </p:sp>
-    </p:spTree>
-  </p:cSld>
-  <p:clrMapOvr>
-    <a:masterClrMapping/>
-  </p:clrMapOvr>
-</p:sld>
-</file>
-
-<file path=ppt/slides/slide4.xml><?xml version="1.0" encoding="utf-8"?>
-<p:sld xmlns:a="http://schemas.openxmlformats.org/drawingml/2006/main" xmlns:r="http://schemas.openxmlformats.org/officeDocument/2006/relationships" xmlns:p="http://schemas.openxmlformats.org/presentationml/2006/main">
-  <p:cSld>
-    <p:spTree>
-      <p:nvGrpSpPr>
-        <p:cNvPr id="1" name=""/>
-        <p:cNvGrpSpPr/>
-        <p:nvPr/>
-      </p:nvGrpSpPr>
-      <p:grpSpPr>
-        <a:xfrm>
-          <a:off x="0" y="0"/>
-          <a:ext cx="0" cy="0"/>
-          <a:chOff x="0" y="0"/>
-          <a:chExt cx="0" cy="0"/>
-        </a:xfrm>
-      </p:grpSpPr>
-      <p:sp>
-        <p:nvSpPr>
-          <p:cNvPr id="4" name="Slide Number Placeholder 3"/>
-          <p:cNvSpPr>
-            <a:spLocks noGrp="1"/>
-          </p:cNvSpPr>
-          <p:nvPr>
-            <p:ph type="sldNum" idx="12"/>
-          </p:nvPr>
-        </p:nvSpPr>
-        <p:spPr/>
-        <p:txBody>
-          <a:bodyPr/>
-          <a:lstStyle/>
-          <a:p>
-            <a:pPr marL="0" lvl="0" indent="0" algn="r" rtl="0">
-              <a:spcBef>
-                <a:spcPts val="0"/>
-              </a:spcBef>
-              <a:spcAft>
-                <a:spcPts val="0"/>
-              </a:spcAft>
-              <a:buNone/>
-            </a:pPr>
-            <a:fld id="{00000000-1234-1234-1234-123412341234}" type="slidenum">
-              <a:rPr lang="en-GB" smtClean="0"/>
-              <a:pPr marL="0" lvl="0" indent="0" algn="r" rtl="0">
-                <a:spcBef>
-                  <a:spcPts val="0"/>
-                </a:spcBef>
-                <a:spcAft>
-                  <a:spcPts val="0"/>
-                </a:spcAft>
-                <a:buNone/>
-              </a:pPr>
-              <a:t>4</a:t>
-            </a:fld>
-            <a:endParaRPr lang="en-GB"/>
-          </a:p>
-        </p:txBody>
-      </p:sp>
       <p:pic>
         <p:nvPicPr>
-          <p:cNvPr id="5" name="Picture 4" descr="Eng_hist.png"/>
+          <p:cNvPr id="2" name="Picture 1" descr="A graph of a stress level&#10;&#10;AI-generated content may be incorrect.">
+            <a:extLst>
+              <a:ext uri="{FF2B5EF4-FFF2-40B4-BE49-F238E27FC236}">
+                <a16:creationId xmlns:a16="http://schemas.microsoft.com/office/drawing/2014/main" id="{1AB3AF68-58FC-0DF7-6216-AFCB8B73A895}"/>
+              </a:ext>
+            </a:extLst>
+          </p:cNvPr>
           <p:cNvPicPr>
             <a:picLocks noChangeAspect="1"/>
           </p:cNvPicPr>
@@ -13782,344 +13701,14 @@
         </p:blipFill>
         <p:spPr>
           <a:xfrm>
-            <a:off x="3155201" y="1547405"/>
-            <a:ext cx="5888024" cy="5116149"/>
+            <a:off x="2536521" y="1534438"/>
+            <a:ext cx="7108521" cy="5323562"/>
           </a:xfrm>
           <a:prstGeom prst="rect">
             <a:avLst/>
           </a:prstGeom>
         </p:spPr>
       </p:pic>
-      <p:sp>
-        <p:nvSpPr>
-          <p:cNvPr id="8" name="Title 1">
-            <a:extLst>
-              <a:ext uri="{FF2B5EF4-FFF2-40B4-BE49-F238E27FC236}">
-                <a16:creationId xmlns:a16="http://schemas.microsoft.com/office/drawing/2014/main" id="{B2CDF961-E94C-A13A-F1D7-B76097DC36DF}"/>
-              </a:ext>
-            </a:extLst>
-          </p:cNvPr>
-          <p:cNvSpPr txBox="1">
-            <a:spLocks/>
-          </p:cNvSpPr>
-          <p:nvPr/>
-        </p:nvSpPr>
-        <p:spPr>
-          <a:xfrm>
-            <a:off x="760216" y="794172"/>
-            <a:ext cx="9770980" cy="681318"/>
-          </a:xfrm>
-          <a:prstGeom prst="rect">
-            <a:avLst/>
-          </a:prstGeom>
-          <a:noFill/>
-          <a:ln>
-            <a:noFill/>
-          </a:ln>
-        </p:spPr>
-        <p:txBody>
-          <a:bodyPr spcFirstLastPara="1" wrap="square" lIns="0" tIns="0" rIns="0" bIns="0" anchor="t" anchorCtr="0">
-            <a:noAutofit/>
-          </a:bodyPr>
-          <a:lstStyle>
-            <a:defPPr marR="0" lvl="0" algn="l" rtl="0">
-              <a:lnSpc>
-                <a:spcPct val="100000"/>
-              </a:lnSpc>
-              <a:spcBef>
-                <a:spcPts val="0"/>
-              </a:spcBef>
-              <a:spcAft>
-                <a:spcPts val="0"/>
-              </a:spcAft>
-            </a:defPPr>
-            <a:lvl1pPr marR="0" lvl="0" algn="l" rtl="0">
-              <a:lnSpc>
-                <a:spcPct val="200000"/>
-              </a:lnSpc>
-              <a:spcBef>
-                <a:spcPts val="0"/>
-              </a:spcBef>
-              <a:spcAft>
-                <a:spcPts val="0"/>
-              </a:spcAft>
-              <a:buClr>
-                <a:srgbClr val="203232"/>
-              </a:buClr>
-              <a:buSzPts val="1800"/>
-              <a:buFont typeface="Arial"/>
-              <a:buNone/>
-              <a:defRPr sz="3600" b="1" i="0" u="none" strike="noStrike" cap="none">
-                <a:solidFill>
-                  <a:srgbClr val="203232"/>
-                </a:solidFill>
-                <a:latin typeface="Arial"/>
-                <a:ea typeface="Arial"/>
-                <a:cs typeface="Arial"/>
-                <a:sym typeface="Arial"/>
-              </a:defRPr>
-            </a:lvl1pPr>
-            <a:lvl2pPr marR="0" lvl="1" algn="l" rtl="0">
-              <a:lnSpc>
-                <a:spcPct val="100000"/>
-              </a:lnSpc>
-              <a:spcBef>
-                <a:spcPts val="0"/>
-              </a:spcBef>
-              <a:spcAft>
-                <a:spcPts val="0"/>
-              </a:spcAft>
-              <a:buClr>
-                <a:srgbClr val="000000"/>
-              </a:buClr>
-              <a:buSzPts val="1400"/>
-              <a:buFont typeface="Arial"/>
-              <a:buNone/>
-              <a:defRPr sz="1800" b="0" i="0" u="none" strike="noStrike" cap="none">
-                <a:solidFill>
-                  <a:srgbClr val="000000"/>
-                </a:solidFill>
-                <a:latin typeface="Arial"/>
-                <a:ea typeface="Arial"/>
-                <a:cs typeface="Arial"/>
-                <a:sym typeface="Arial"/>
-              </a:defRPr>
-            </a:lvl2pPr>
-            <a:lvl3pPr marR="0" lvl="2" algn="l" rtl="0">
-              <a:lnSpc>
-                <a:spcPct val="100000"/>
-              </a:lnSpc>
-              <a:spcBef>
-                <a:spcPts val="0"/>
-              </a:spcBef>
-              <a:spcAft>
-                <a:spcPts val="0"/>
-              </a:spcAft>
-              <a:buClr>
-                <a:srgbClr val="000000"/>
-              </a:buClr>
-              <a:buSzPts val="1400"/>
-              <a:buFont typeface="Arial"/>
-              <a:buNone/>
-              <a:defRPr sz="1800" b="0" i="0" u="none" strike="noStrike" cap="none">
-                <a:solidFill>
-                  <a:srgbClr val="000000"/>
-                </a:solidFill>
-                <a:latin typeface="Arial"/>
-                <a:ea typeface="Arial"/>
-                <a:cs typeface="Arial"/>
-                <a:sym typeface="Arial"/>
-              </a:defRPr>
-            </a:lvl3pPr>
-            <a:lvl4pPr marR="0" lvl="3" algn="l" rtl="0">
-              <a:lnSpc>
-                <a:spcPct val="100000"/>
-              </a:lnSpc>
-              <a:spcBef>
-                <a:spcPts val="0"/>
-              </a:spcBef>
-              <a:spcAft>
-                <a:spcPts val="0"/>
-              </a:spcAft>
-              <a:buClr>
-                <a:srgbClr val="000000"/>
-              </a:buClr>
-              <a:buSzPts val="1400"/>
-              <a:buFont typeface="Arial"/>
-              <a:buNone/>
-              <a:defRPr sz="1800" b="0" i="0" u="none" strike="noStrike" cap="none">
-                <a:solidFill>
-                  <a:srgbClr val="000000"/>
-                </a:solidFill>
-                <a:latin typeface="Arial"/>
-                <a:ea typeface="Arial"/>
-                <a:cs typeface="Arial"/>
-                <a:sym typeface="Arial"/>
-              </a:defRPr>
-            </a:lvl4pPr>
-            <a:lvl5pPr marR="0" lvl="4" algn="l" rtl="0">
-              <a:lnSpc>
-                <a:spcPct val="100000"/>
-              </a:lnSpc>
-              <a:spcBef>
-                <a:spcPts val="0"/>
-              </a:spcBef>
-              <a:spcAft>
-                <a:spcPts val="0"/>
-              </a:spcAft>
-              <a:buClr>
-                <a:srgbClr val="000000"/>
-              </a:buClr>
-              <a:buSzPts val="1400"/>
-              <a:buFont typeface="Arial"/>
-              <a:buNone/>
-              <a:defRPr sz="1800" b="0" i="0" u="none" strike="noStrike" cap="none">
-                <a:solidFill>
-                  <a:srgbClr val="000000"/>
-                </a:solidFill>
-                <a:latin typeface="Arial"/>
-                <a:ea typeface="Arial"/>
-                <a:cs typeface="Arial"/>
-                <a:sym typeface="Arial"/>
-              </a:defRPr>
-            </a:lvl5pPr>
-            <a:lvl6pPr marR="0" lvl="5" algn="l" rtl="0">
-              <a:lnSpc>
-                <a:spcPct val="100000"/>
-              </a:lnSpc>
-              <a:spcBef>
-                <a:spcPts val="0"/>
-              </a:spcBef>
-              <a:spcAft>
-                <a:spcPts val="0"/>
-              </a:spcAft>
-              <a:buClr>
-                <a:srgbClr val="000000"/>
-              </a:buClr>
-              <a:buSzPts val="1400"/>
-              <a:buFont typeface="Arial"/>
-              <a:buNone/>
-              <a:defRPr sz="1800" b="0" i="0" u="none" strike="noStrike" cap="none">
-                <a:solidFill>
-                  <a:srgbClr val="000000"/>
-                </a:solidFill>
-                <a:latin typeface="Arial"/>
-                <a:ea typeface="Arial"/>
-                <a:cs typeface="Arial"/>
-                <a:sym typeface="Arial"/>
-              </a:defRPr>
-            </a:lvl6pPr>
-            <a:lvl7pPr marR="0" lvl="6" algn="l" rtl="0">
-              <a:lnSpc>
-                <a:spcPct val="100000"/>
-              </a:lnSpc>
-              <a:spcBef>
-                <a:spcPts val="0"/>
-              </a:spcBef>
-              <a:spcAft>
-                <a:spcPts val="0"/>
-              </a:spcAft>
-              <a:buClr>
-                <a:srgbClr val="000000"/>
-              </a:buClr>
-              <a:buSzPts val="1400"/>
-              <a:buFont typeface="Arial"/>
-              <a:buNone/>
-              <a:defRPr sz="1800" b="0" i="0" u="none" strike="noStrike" cap="none">
-                <a:solidFill>
-                  <a:srgbClr val="000000"/>
-                </a:solidFill>
-                <a:latin typeface="Arial"/>
-                <a:ea typeface="Arial"/>
-                <a:cs typeface="Arial"/>
-                <a:sym typeface="Arial"/>
-              </a:defRPr>
-            </a:lvl7pPr>
-            <a:lvl8pPr marR="0" lvl="7" algn="l" rtl="0">
-              <a:lnSpc>
-                <a:spcPct val="100000"/>
-              </a:lnSpc>
-              <a:spcBef>
-                <a:spcPts val="0"/>
-              </a:spcBef>
-              <a:spcAft>
-                <a:spcPts val="0"/>
-              </a:spcAft>
-              <a:buClr>
-                <a:srgbClr val="000000"/>
-              </a:buClr>
-              <a:buSzPts val="1400"/>
-              <a:buFont typeface="Arial"/>
-              <a:buNone/>
-              <a:defRPr sz="1800" b="0" i="0" u="none" strike="noStrike" cap="none">
-                <a:solidFill>
-                  <a:srgbClr val="000000"/>
-                </a:solidFill>
-                <a:latin typeface="Arial"/>
-                <a:ea typeface="Arial"/>
-                <a:cs typeface="Arial"/>
-                <a:sym typeface="Arial"/>
-              </a:defRPr>
-            </a:lvl8pPr>
-            <a:lvl9pPr marR="0" lvl="8" algn="l" rtl="0">
-              <a:lnSpc>
-                <a:spcPct val="100000"/>
-              </a:lnSpc>
-              <a:spcBef>
-                <a:spcPts val="0"/>
-              </a:spcBef>
-              <a:spcAft>
-                <a:spcPts val="0"/>
-              </a:spcAft>
-              <a:buClr>
-                <a:srgbClr val="000000"/>
-              </a:buClr>
-              <a:buSzPts val="1400"/>
-              <a:buFont typeface="Arial"/>
-              <a:buNone/>
-              <a:defRPr sz="1800" b="0" i="0" u="none" strike="noStrike" cap="none">
-                <a:solidFill>
-                  <a:srgbClr val="000000"/>
-                </a:solidFill>
-                <a:latin typeface="Arial"/>
-                <a:ea typeface="Arial"/>
-                <a:cs typeface="Arial"/>
-                <a:sym typeface="Arial"/>
-              </a:defRPr>
-            </a:lvl9pPr>
-          </a:lstStyle>
-          <a:p>
-            <a:r>
-              <a:rPr lang="en-US" sz="2800" dirty="0"/>
-              <a:t>Graph 2: Histogram for stress level among engineers</a:t>
-            </a:r>
-            <a:endParaRPr lang="en-US" dirty="0"/>
-          </a:p>
-        </p:txBody>
-      </p:sp>
-      <p:sp>
-        <p:nvSpPr>
-          <p:cNvPr id="12" name="Google Shape;100;p17">
-            <a:extLst>
-              <a:ext uri="{FF2B5EF4-FFF2-40B4-BE49-F238E27FC236}">
-                <a16:creationId xmlns:a16="http://schemas.microsoft.com/office/drawing/2014/main" id="{EC933DAC-B39E-AF9D-1A78-C3C92724B311}"/>
-              </a:ext>
-            </a:extLst>
-          </p:cNvPr>
-          <p:cNvSpPr txBox="1">
-            <a:spLocks noGrp="1"/>
-          </p:cNvSpPr>
-          <p:nvPr>
-            <p:ph type="ftr" idx="11"/>
-          </p:nvPr>
-        </p:nvSpPr>
-        <p:spPr>
-          <a:xfrm>
-            <a:off x="755462" y="548066"/>
-            <a:ext cx="10104598" cy="242037"/>
-          </a:xfrm>
-          <a:prstGeom prst="rect">
-            <a:avLst/>
-          </a:prstGeom>
-          <a:noFill/>
-          <a:ln>
-            <a:noFill/>
-          </a:ln>
-        </p:spPr>
-        <p:txBody>
-          <a:bodyPr spcFirstLastPara="1" wrap="square" lIns="0" tIns="0" rIns="0" bIns="0" anchor="t" anchorCtr="0">
-            <a:noAutofit/>
-          </a:bodyPr>
-          <a:lstStyle/>
-          <a:p>
-            <a:r>
-              <a:rPr lang="en-GB" dirty="0"/>
-              <a:t>7COM1079-2025  Student Group No:    A 104    Names of Student Group Attendees: All group members</a:t>
-            </a:r>
-            <a:endParaRPr dirty="0"/>
-          </a:p>
-        </p:txBody>
-      </p:sp>
     </p:spTree>
   </p:cSld>
   <p:clrMapOvr>
@@ -14128,7 +13717,7 @@
 </p:sld>
 </file>
 
-<file path=ppt/slides/slide5.xml><?xml version="1.0" encoding="utf-8"?>
+<file path=ppt/slides/slide4.xml><?xml version="1.0" encoding="utf-8"?>
 <p:sld xmlns:a="http://schemas.openxmlformats.org/drawingml/2006/main" xmlns:r="http://schemas.openxmlformats.org/officeDocument/2006/relationships" xmlns:p="http://schemas.openxmlformats.org/presentationml/2006/main">
   <p:cSld>
     <p:spTree>
@@ -14192,7 +13781,7 @@
                 </a:spcAft>
                 <a:buNone/>
               </a:pPr>
-              <a:t>5</a:t>
+              <a:t>4</a:t>
             </a:fld>
             <a:endParaRPr lang="en-GB"/>
           </a:p>
@@ -14214,7 +13803,7 @@
         </p:nvSpPr>
         <p:spPr>
           <a:xfrm>
-            <a:off x="738130" y="893564"/>
+            <a:off x="759007" y="789180"/>
             <a:ext cx="10477759" cy="813839"/>
           </a:xfrm>
           <a:prstGeom prst="rect">
@@ -14479,9 +14068,9 @@
           <a:p>
             <a:r>
               <a:rPr lang="en-US" sz="2800" dirty="0"/>
-              <a:t>Graph 3: Box Plot for stress levels among both occupations</a:t>
+              <a:t>Graph 2: Box Plot for stress levels among both occupations</a:t>
             </a:r>
-            <a:endParaRPr lang="en-US" dirty="0"/>
+            <a:endParaRPr lang="en-US" sz="2800"/>
           </a:p>
         </p:txBody>
       </p:sp>
@@ -14507,8 +14096,8 @@
         </p:blipFill>
         <p:spPr>
           <a:xfrm>
-            <a:off x="2647282" y="1899234"/>
-            <a:ext cx="6894898" cy="4443255"/>
+            <a:off x="2135802" y="1606960"/>
+            <a:ext cx="7928295" cy="5111309"/>
           </a:xfrm>
           <a:prstGeom prst="rect">
             <a:avLst/>
@@ -14566,6 +14155,2089 @@
     <p:extLst>
       <p:ext uri="{BB962C8B-B14F-4D97-AF65-F5344CB8AC3E}">
         <p14:creationId xmlns:p14="http://schemas.microsoft.com/office/powerpoint/2010/main" val="1903470934"/>
+      </p:ext>
+    </p:extLst>
+  </p:cSld>
+  <p:clrMapOvr>
+    <a:masterClrMapping/>
+  </p:clrMapOvr>
+</p:sld>
+</file>
+
+<file path=ppt/slides/slide5.xml><?xml version="1.0" encoding="utf-8"?>
+<p:sld xmlns:a="http://schemas.openxmlformats.org/drawingml/2006/main" xmlns:r="http://schemas.openxmlformats.org/officeDocument/2006/relationships" xmlns:p="http://schemas.openxmlformats.org/presentationml/2006/main">
+  <p:cSld>
+    <p:spTree>
+      <p:nvGrpSpPr>
+        <p:cNvPr id="1" name=""/>
+        <p:cNvGrpSpPr/>
+        <p:nvPr/>
+      </p:nvGrpSpPr>
+      <p:grpSpPr>
+        <a:xfrm>
+          <a:off x="0" y="0"/>
+          <a:ext cx="0" cy="0"/>
+          <a:chOff x="0" y="0"/>
+          <a:chExt cx="0" cy="0"/>
+        </a:xfrm>
+      </p:grpSpPr>
+      <p:sp>
+        <p:nvSpPr>
+          <p:cNvPr id="104" name="CustomShape 1"/>
+          <p:cNvSpPr/>
+          <p:nvPr/>
+        </p:nvSpPr>
+        <p:spPr>
+          <a:xfrm>
+            <a:off x="0" y="0"/>
+            <a:ext cx="12191760" cy="6857640"/>
+          </a:xfrm>
+          <a:prstGeom prst="rect">
+            <a:avLst/>
+          </a:prstGeom>
+          <a:solidFill>
+            <a:schemeClr val="bg1"/>
+          </a:solidFill>
+          <a:ln>
+            <a:noFill/>
+          </a:ln>
+        </p:spPr>
+        <p:style>
+          <a:lnRef idx="2">
+            <a:schemeClr val="accent1">
+              <a:shade val="50000"/>
+            </a:schemeClr>
+          </a:lnRef>
+          <a:fillRef idx="1">
+            <a:schemeClr val="accent1"/>
+          </a:fillRef>
+          <a:effectRef idx="0">
+            <a:schemeClr val="accent1"/>
+          </a:effectRef>
+          <a:fontRef idx="minor"/>
+        </p:style>
+        <p:txBody>
+          <a:bodyPr/>
+          <a:lstStyle/>
+          <a:p>
+            <a:endParaRPr lang="en-GB"/>
+          </a:p>
+        </p:txBody>
+      </p:sp>
+      <p:sp>
+        <p:nvSpPr>
+          <p:cNvPr id="105" name="CustomShape 2"/>
+          <p:cNvSpPr/>
+          <p:nvPr/>
+        </p:nvSpPr>
+        <p:spPr>
+          <a:xfrm rot="10800000" flipH="1">
+            <a:off x="360" y="360"/>
+            <a:ext cx="12191760" cy="1575720"/>
+          </a:xfrm>
+          <a:prstGeom prst="rect">
+            <a:avLst/>
+          </a:prstGeom>
+          <a:gradFill rotWithShape="0">
+            <a:gsLst>
+              <a:gs pos="0">
+                <a:srgbClr val="000000">
+                  <a:alpha val="96078"/>
+                </a:srgbClr>
+              </a:gs>
+              <a:gs pos="100000">
+                <a:srgbClr val="77418E"/>
+              </a:gs>
+            </a:gsLst>
+            <a:lin ang="15600000"/>
+          </a:gradFill>
+          <a:ln>
+            <a:noFill/>
+          </a:ln>
+        </p:spPr>
+        <p:style>
+          <a:lnRef idx="2">
+            <a:schemeClr val="accent1">
+              <a:shade val="50000"/>
+            </a:schemeClr>
+          </a:lnRef>
+          <a:fillRef idx="1">
+            <a:schemeClr val="accent1"/>
+          </a:fillRef>
+          <a:effectRef idx="0">
+            <a:schemeClr val="accent1"/>
+          </a:effectRef>
+          <a:fontRef idx="minor"/>
+        </p:style>
+        <p:txBody>
+          <a:bodyPr/>
+          <a:lstStyle/>
+          <a:p>
+            <a:endParaRPr lang="en-GB"/>
+          </a:p>
+        </p:txBody>
+      </p:sp>
+      <p:sp>
+        <p:nvSpPr>
+          <p:cNvPr id="106" name="CustomShape 3"/>
+          <p:cNvSpPr/>
+          <p:nvPr/>
+        </p:nvSpPr>
+        <p:spPr>
+          <a:xfrm>
+            <a:off x="0" y="0"/>
+            <a:ext cx="8128440" cy="1575000"/>
+          </a:xfrm>
+          <a:prstGeom prst="rect">
+            <a:avLst/>
+          </a:prstGeom>
+          <a:gradFill rotWithShape="0">
+            <a:gsLst>
+              <a:gs pos="26000">
+                <a:srgbClr val="C49FD3">
+                  <a:alpha val="0"/>
+                </a:srgbClr>
+              </a:gs>
+              <a:gs pos="100000">
+                <a:srgbClr val="9C5FB5">
+                  <a:alpha val="41176"/>
+                </a:srgbClr>
+              </a:gs>
+            </a:gsLst>
+            <a:lin ang="19200000"/>
+          </a:gradFill>
+          <a:ln>
+            <a:noFill/>
+          </a:ln>
+        </p:spPr>
+        <p:style>
+          <a:lnRef idx="2">
+            <a:schemeClr val="accent1">
+              <a:shade val="50000"/>
+            </a:schemeClr>
+          </a:lnRef>
+          <a:fillRef idx="1">
+            <a:schemeClr val="accent1"/>
+          </a:fillRef>
+          <a:effectRef idx="0">
+            <a:schemeClr val="accent1"/>
+          </a:effectRef>
+          <a:fontRef idx="minor"/>
+        </p:style>
+        <p:txBody>
+          <a:bodyPr/>
+          <a:lstStyle/>
+          <a:p>
+            <a:endParaRPr lang="en-GB"/>
+          </a:p>
+        </p:txBody>
+      </p:sp>
+      <p:sp>
+        <p:nvSpPr>
+          <p:cNvPr id="107" name="CustomShape 4"/>
+          <p:cNvSpPr/>
+          <p:nvPr/>
+        </p:nvSpPr>
+        <p:spPr>
+          <a:xfrm flipH="1">
+            <a:off x="0" y="0"/>
+            <a:ext cx="12191760" cy="1573920"/>
+          </a:xfrm>
+          <a:prstGeom prst="rect">
+            <a:avLst/>
+          </a:prstGeom>
+          <a:gradFill rotWithShape="0">
+            <a:gsLst>
+              <a:gs pos="22000">
+                <a:srgbClr val="9C5FB5">
+                  <a:alpha val="15294"/>
+                </a:srgbClr>
+              </a:gs>
+              <a:gs pos="100000">
+                <a:srgbClr val="000000">
+                  <a:alpha val="63137"/>
+                </a:srgbClr>
+              </a:gs>
+            </a:gsLst>
+            <a:lin ang="6000000"/>
+          </a:gradFill>
+          <a:ln>
+            <a:noFill/>
+          </a:ln>
+        </p:spPr>
+        <p:style>
+          <a:lnRef idx="2">
+            <a:schemeClr val="accent1">
+              <a:shade val="50000"/>
+            </a:schemeClr>
+          </a:lnRef>
+          <a:fillRef idx="1">
+            <a:schemeClr val="accent1"/>
+          </a:fillRef>
+          <a:effectRef idx="0">
+            <a:schemeClr val="accent1"/>
+          </a:effectRef>
+          <a:fontRef idx="minor"/>
+        </p:style>
+        <p:txBody>
+          <a:bodyPr/>
+          <a:lstStyle/>
+          <a:p>
+            <a:endParaRPr lang="en-GB"/>
+          </a:p>
+        </p:txBody>
+      </p:sp>
+      <p:sp>
+        <p:nvSpPr>
+          <p:cNvPr id="108" name="TextShape 5"/>
+          <p:cNvSpPr txBox="1"/>
+          <p:nvPr/>
+        </p:nvSpPr>
+        <p:spPr>
+          <a:xfrm>
+            <a:off x="290880" y="158400"/>
+            <a:ext cx="7063200" cy="1158840"/>
+          </a:xfrm>
+          <a:prstGeom prst="rect">
+            <a:avLst/>
+          </a:prstGeom>
+          <a:noFill/>
+          <a:ln>
+            <a:noFill/>
+          </a:ln>
+        </p:spPr>
+        <p:txBody>
+          <a:bodyPr anchor="ctr">
+            <a:normAutofit/>
+          </a:bodyPr>
+          <a:lstStyle/>
+          <a:p>
+            <a:pPr>
+              <a:lnSpc>
+                <a:spcPct val="90000"/>
+              </a:lnSpc>
+            </a:pPr>
+            <a:r>
+              <a:rPr lang="en-US" sz="2400" b="0" strike="noStrike" spc="-202">
+                <a:solidFill>
+                  <a:srgbClr val="FFFFFF"/>
+                </a:solidFill>
+                <a:latin typeface="Arial"/>
+              </a:rPr>
+              <a:t> </a:t>
+            </a:r>
+            <a:br/>
+            <a:br/>
+            <a:endParaRPr lang="en-US" sz="2400" b="0" strike="noStrike" spc="-1">
+              <a:solidFill>
+                <a:srgbClr val="203232"/>
+              </a:solidFill>
+              <a:latin typeface="Arial"/>
+            </a:endParaRPr>
+          </a:p>
+        </p:txBody>
+      </p:sp>
+      <p:sp>
+        <p:nvSpPr>
+          <p:cNvPr id="109" name="TextShape 6"/>
+          <p:cNvSpPr txBox="1"/>
+          <p:nvPr/>
+        </p:nvSpPr>
+        <p:spPr>
+          <a:xfrm>
+            <a:off x="7354080" y="203882"/>
+            <a:ext cx="4705437" cy="1158840"/>
+          </a:xfrm>
+          <a:prstGeom prst="rect">
+            <a:avLst/>
+          </a:prstGeom>
+          <a:noFill/>
+          <a:ln>
+            <a:noFill/>
+          </a:ln>
+        </p:spPr>
+        <p:txBody>
+          <a:bodyPr anchor="ctr">
+            <a:noAutofit/>
+          </a:bodyPr>
+          <a:lstStyle/>
+          <a:p>
+            <a:pPr>
+              <a:lnSpc>
+                <a:spcPts val="2880"/>
+              </a:lnSpc>
+              <a:spcAft>
+                <a:spcPts val="992"/>
+              </a:spcAft>
+              <a:tabLst>
+                <a:tab pos="0" algn="l"/>
+              </a:tabLst>
+            </a:pPr>
+            <a:r>
+              <a:rPr lang="en-GB" sz="3000" b="1" strike="noStrike" spc="-100">
+                <a:solidFill>
+                  <a:srgbClr val="FFFFFF"/>
+                </a:solidFill>
+                <a:latin typeface="Arial"/>
+              </a:rPr>
+              <a:t>Our RQ asks about Differences in means/ medians </a:t>
+            </a:r>
+            <a:endParaRPr lang="en-US" sz="3000" b="1" strike="noStrike" spc="-1">
+              <a:latin typeface="Arial"/>
+            </a:endParaRPr>
+          </a:p>
+        </p:txBody>
+      </p:sp>
+      <p:sp>
+        <p:nvSpPr>
+          <p:cNvPr id="110" name="TextShape 7"/>
+          <p:cNvSpPr txBox="1"/>
+          <p:nvPr/>
+        </p:nvSpPr>
+        <p:spPr>
+          <a:xfrm>
+            <a:off x="11704320" y="6455520"/>
+            <a:ext cx="447840" cy="364680"/>
+          </a:xfrm>
+          <a:prstGeom prst="rect">
+            <a:avLst/>
+          </a:prstGeom>
+          <a:noFill/>
+          <a:ln>
+            <a:noFill/>
+          </a:ln>
+        </p:spPr>
+        <p:txBody>
+          <a:bodyPr anchor="ctr">
+            <a:normAutofit/>
+          </a:bodyPr>
+          <a:lstStyle/>
+          <a:p>
+            <a:pPr algn="r">
+              <a:lnSpc>
+                <a:spcPct val="100000"/>
+              </a:lnSpc>
+              <a:spcAft>
+                <a:spcPts val="601"/>
+              </a:spcAft>
+            </a:pPr>
+            <a:fld id="{29CEFF96-2F62-4B45-8A43-FC60A0A96C7C}" type="slidenum">
+              <a:rPr lang="en-US" sz="1100" b="1" strike="noStrike" spc="-1">
+                <a:solidFill>
+                  <a:srgbClr val="7DABAB"/>
+                </a:solidFill>
+                <a:latin typeface="Arial"/>
+              </a:rPr>
+              <a:t>5</a:t>
+            </a:fld>
+            <a:endParaRPr lang="en-US" sz="1100" b="0" strike="noStrike" spc="-1">
+              <a:latin typeface="Times New Roman"/>
+            </a:endParaRPr>
+          </a:p>
+        </p:txBody>
+      </p:sp>
+      <p:sp>
+        <p:nvSpPr>
+          <p:cNvPr id="111" name="CustomShape 8"/>
+          <p:cNvSpPr/>
+          <p:nvPr/>
+        </p:nvSpPr>
+        <p:spPr>
+          <a:xfrm>
+            <a:off x="366120" y="197640"/>
+            <a:ext cx="6988320" cy="1187640"/>
+          </a:xfrm>
+          <a:prstGeom prst="rect">
+            <a:avLst/>
+          </a:prstGeom>
+          <a:noFill/>
+          <a:ln>
+            <a:noFill/>
+          </a:ln>
+        </p:spPr>
+        <p:style>
+          <a:lnRef idx="0">
+            <a:scrgbClr r="0" g="0" b="0"/>
+          </a:lnRef>
+          <a:fillRef idx="0">
+            <a:scrgbClr r="0" g="0" b="0"/>
+          </a:fillRef>
+          <a:effectRef idx="0">
+            <a:scrgbClr r="0" g="0" b="0"/>
+          </a:effectRef>
+          <a:fontRef idx="minor"/>
+        </p:style>
+        <p:txBody>
+          <a:bodyPr lIns="90000" tIns="45000" rIns="90000" bIns="45000" anchor="t">
+            <a:spAutoFit/>
+          </a:bodyPr>
+          <a:lstStyle/>
+          <a:p>
+            <a:r>
+              <a:rPr lang="en-GB" sz="2400" b="0" strike="noStrike" spc="-1" dirty="0">
+                <a:solidFill>
+                  <a:srgbClr val="FFFFFF"/>
+                </a:solidFill>
+                <a:latin typeface="Arial"/>
+              </a:rPr>
+              <a:t>Here is a </a:t>
+            </a:r>
+            <a:r>
+              <a:rPr lang="en-GB" sz="2400" b="1" strike="noStrike" spc="-1" dirty="0">
+                <a:solidFill>
+                  <a:srgbClr val="FFFFFF"/>
+                </a:solidFill>
+                <a:latin typeface="Arial"/>
+              </a:rPr>
+              <a:t>Histogram </a:t>
+            </a:r>
+            <a:r>
+              <a:rPr lang="en-GB" sz="2400" b="0" strike="noStrike" spc="-1" dirty="0">
+                <a:solidFill>
+                  <a:srgbClr val="FFFFFF"/>
+                </a:solidFill>
+                <a:latin typeface="Arial"/>
+              </a:rPr>
+              <a:t>showing the frequencies of our dependent variable to include the normal curve overlay</a:t>
+            </a:r>
+            <a:r>
+              <a:rPr lang="en-GB" sz="2400" spc="-1" dirty="0">
+                <a:solidFill>
+                  <a:srgbClr val="FFFFFF"/>
+                </a:solidFill>
+                <a:latin typeface="Arial"/>
+              </a:rPr>
+              <a:t> (shown in blue)</a:t>
+            </a:r>
+            <a:r>
+              <a:rPr lang="en-GB" sz="1800" spc="-1" dirty="0">
+                <a:solidFill>
+                  <a:srgbClr val="203232"/>
+                </a:solidFill>
+                <a:latin typeface="Arial"/>
+              </a:rPr>
+              <a:t>.</a:t>
+            </a:r>
+            <a:endParaRPr lang="en-US" sz="1800" b="0" strike="noStrike" spc="-1" dirty="0">
+              <a:latin typeface="Arial"/>
+            </a:endParaRPr>
+          </a:p>
+        </p:txBody>
+      </p:sp>
+      <p:sp>
+        <p:nvSpPr>
+          <p:cNvPr id="112" name="CustomShape 9"/>
+          <p:cNvSpPr/>
+          <p:nvPr/>
+        </p:nvSpPr>
+        <p:spPr>
+          <a:xfrm>
+            <a:off x="290880" y="1627560"/>
+            <a:ext cx="10865160" cy="4886280"/>
+          </a:xfrm>
+          <a:prstGeom prst="roundRect">
+            <a:avLst>
+              <a:gd name="adj" fmla="val 16667"/>
+            </a:avLst>
+          </a:prstGeom>
+          <a:solidFill>
+            <a:schemeClr val="accent1">
+              <a:lumMod val="20000"/>
+              <a:lumOff val="80000"/>
+            </a:schemeClr>
+          </a:solidFill>
+          <a:ln/>
+        </p:spPr>
+        <p:style>
+          <a:lnRef idx="2">
+            <a:schemeClr val="accent1">
+              <a:shade val="50000"/>
+            </a:schemeClr>
+          </a:lnRef>
+          <a:fillRef idx="1">
+            <a:schemeClr val="accent1"/>
+          </a:fillRef>
+          <a:effectRef idx="0">
+            <a:schemeClr val="accent1"/>
+          </a:effectRef>
+          <a:fontRef idx="minor"/>
+        </p:style>
+        <p:txBody>
+          <a:bodyPr lIns="90000" tIns="45000" rIns="90000" bIns="45000" anchor="ctr">
+            <a:noAutofit/>
+          </a:bodyPr>
+          <a:lstStyle/>
+          <a:p>
+            <a:pPr>
+              <a:lnSpc>
+                <a:spcPct val="100000"/>
+              </a:lnSpc>
+            </a:pPr>
+            <a:endParaRPr lang="en-GB" sz="1800" b="0" strike="noStrike" spc="-1" dirty="0">
+              <a:latin typeface="Arial"/>
+              <a:cs typeface="Arial"/>
+            </a:endParaRPr>
+          </a:p>
+          <a:p>
+            <a:pPr>
+              <a:lnSpc>
+                <a:spcPct val="100000"/>
+              </a:lnSpc>
+            </a:pPr>
+            <a:endParaRPr lang="en-US" sz="1800" b="0" strike="noStrike" spc="-1">
+              <a:latin typeface="Arial"/>
+            </a:endParaRPr>
+          </a:p>
+          <a:p>
+            <a:pPr>
+              <a:lnSpc>
+                <a:spcPct val="100000"/>
+              </a:lnSpc>
+            </a:pPr>
+            <a:endParaRPr lang="en-US" sz="1800" b="0" strike="noStrike" spc="-1">
+              <a:latin typeface="Arial"/>
+            </a:endParaRPr>
+          </a:p>
+          <a:p>
+            <a:pPr>
+              <a:lnSpc>
+                <a:spcPct val="100000"/>
+              </a:lnSpc>
+            </a:pPr>
+            <a:endParaRPr lang="en-US" sz="1800" b="0" strike="noStrike" spc="-1">
+              <a:latin typeface="Arial"/>
+            </a:endParaRPr>
+          </a:p>
+          <a:p>
+            <a:pPr>
+              <a:lnSpc>
+                <a:spcPct val="100000"/>
+              </a:lnSpc>
+            </a:pPr>
+            <a:endParaRPr lang="en-US" sz="1800" b="0" strike="noStrike" spc="-1">
+              <a:latin typeface="Arial"/>
+            </a:endParaRPr>
+          </a:p>
+          <a:p>
+            <a:pPr>
+              <a:lnSpc>
+                <a:spcPct val="100000"/>
+              </a:lnSpc>
+            </a:pPr>
+            <a:endParaRPr lang="en-US" sz="1800" b="0" strike="noStrike" spc="-1">
+              <a:latin typeface="Arial"/>
+            </a:endParaRPr>
+          </a:p>
+          <a:p>
+            <a:pPr>
+              <a:lnSpc>
+                <a:spcPct val="100000"/>
+              </a:lnSpc>
+            </a:pPr>
+            <a:endParaRPr lang="en-US" sz="1800" b="0" strike="noStrike" spc="-1">
+              <a:latin typeface="Arial"/>
+            </a:endParaRPr>
+          </a:p>
+          <a:p>
+            <a:pPr>
+              <a:lnSpc>
+                <a:spcPct val="100000"/>
+              </a:lnSpc>
+            </a:pPr>
+            <a:endParaRPr lang="en-US" sz="1800" b="0" strike="noStrike" spc="-1">
+              <a:latin typeface="Arial"/>
+            </a:endParaRPr>
+          </a:p>
+          <a:p>
+            <a:pPr>
+              <a:lnSpc>
+                <a:spcPct val="100000"/>
+              </a:lnSpc>
+            </a:pPr>
+            <a:endParaRPr lang="en-US" sz="1800" b="0" strike="noStrike" spc="-1">
+              <a:latin typeface="Arial"/>
+            </a:endParaRPr>
+          </a:p>
+          <a:p>
+            <a:pPr>
+              <a:lnSpc>
+                <a:spcPct val="100000"/>
+              </a:lnSpc>
+            </a:pPr>
+            <a:endParaRPr lang="en-US" sz="1800" b="0" strike="noStrike" spc="-1">
+              <a:latin typeface="Arial"/>
+            </a:endParaRPr>
+          </a:p>
+          <a:p>
+            <a:pPr>
+              <a:lnSpc>
+                <a:spcPct val="100000"/>
+              </a:lnSpc>
+            </a:pPr>
+            <a:endParaRPr lang="en-US" sz="1800" b="0" strike="noStrike" spc="-1">
+              <a:latin typeface="Arial"/>
+            </a:endParaRPr>
+          </a:p>
+          <a:p>
+            <a:pPr>
+              <a:lnSpc>
+                <a:spcPct val="100000"/>
+              </a:lnSpc>
+            </a:pPr>
+            <a:endParaRPr lang="en-US" sz="1800" b="0" strike="noStrike" spc="-1">
+              <a:latin typeface="Arial"/>
+            </a:endParaRPr>
+          </a:p>
+          <a:p>
+            <a:pPr>
+              <a:lnSpc>
+                <a:spcPct val="100000"/>
+              </a:lnSpc>
+            </a:pPr>
+            <a:endParaRPr lang="en-US" sz="1800" b="0" strike="noStrike" spc="-1">
+              <a:latin typeface="Arial"/>
+            </a:endParaRPr>
+          </a:p>
+          <a:p>
+            <a:pPr>
+              <a:lnSpc>
+                <a:spcPct val="100000"/>
+              </a:lnSpc>
+            </a:pPr>
+            <a:endParaRPr lang="en-US" sz="1800" b="0" strike="noStrike" spc="-1">
+              <a:latin typeface="Arial"/>
+            </a:endParaRPr>
+          </a:p>
+          <a:p>
+            <a:pPr>
+              <a:lnSpc>
+                <a:spcPct val="100000"/>
+              </a:lnSpc>
+            </a:pPr>
+            <a:endParaRPr lang="en-US" sz="1800" b="0" strike="noStrike" spc="-1">
+              <a:latin typeface="Arial"/>
+            </a:endParaRPr>
+          </a:p>
+          <a:p>
+            <a:pPr>
+              <a:lnSpc>
+                <a:spcPct val="100000"/>
+              </a:lnSpc>
+            </a:pPr>
+            <a:endParaRPr lang="en-US" sz="1800" b="0" strike="noStrike" spc="-1">
+              <a:latin typeface="Arial"/>
+            </a:endParaRPr>
+          </a:p>
+        </p:txBody>
+      </p:sp>
+      <p:sp>
+        <p:nvSpPr>
+          <p:cNvPr id="113" name="CustomShape 10"/>
+          <p:cNvSpPr/>
+          <p:nvPr/>
+        </p:nvSpPr>
+        <p:spPr>
+          <a:xfrm>
+            <a:off x="6682753" y="1999947"/>
+            <a:ext cx="4475760" cy="2860868"/>
+          </a:xfrm>
+          <a:prstGeom prst="rect">
+            <a:avLst/>
+          </a:prstGeom>
+          <a:noFill/>
+          <a:ln>
+            <a:noFill/>
+          </a:ln>
+        </p:spPr>
+        <p:style>
+          <a:lnRef idx="0">
+            <a:scrgbClr r="0" g="0" b="0"/>
+          </a:lnRef>
+          <a:fillRef idx="0">
+            <a:scrgbClr r="0" g="0" b="0"/>
+          </a:fillRef>
+          <a:effectRef idx="0">
+            <a:scrgbClr r="0" g="0" b="0"/>
+          </a:effectRef>
+          <a:fontRef idx="minor"/>
+        </p:style>
+        <p:txBody>
+          <a:bodyPr wrap="square" lIns="90000" tIns="45000" rIns="90000" bIns="45000" anchor="t">
+            <a:spAutoFit/>
+          </a:bodyPr>
+          <a:lstStyle/>
+          <a:p>
+            <a:pPr>
+              <a:lnSpc>
+                <a:spcPct val="100000"/>
+              </a:lnSpc>
+            </a:pPr>
+            <a:r>
+              <a:rPr lang="en-GB" sz="1800" b="0" strike="noStrike" spc="-1" dirty="0">
+                <a:solidFill>
+                  <a:srgbClr val="203232"/>
+                </a:solidFill>
+                <a:latin typeface="Arial"/>
+              </a:rPr>
+              <a:t>The normal curve overlay </a:t>
+            </a:r>
+            <a:r>
+              <a:rPr lang="en-GB" sz="1800" b="1" i="1" strike="noStrike" spc="-1" dirty="0">
+                <a:solidFill>
+                  <a:srgbClr val="203232"/>
+                </a:solidFill>
+                <a:latin typeface="Arial"/>
+              </a:rPr>
+              <a:t>does not follow</a:t>
+            </a:r>
+            <a:r>
+              <a:rPr lang="en-GB" sz="1800" b="0" strike="noStrike" spc="-1" dirty="0">
+                <a:solidFill>
+                  <a:srgbClr val="203232"/>
+                </a:solidFill>
+                <a:latin typeface="Arial"/>
+              </a:rPr>
+              <a:t> the shape of the underlying data, so we use the non-parametric test that does not assume normality: </a:t>
+            </a:r>
+            <a:r>
+              <a:rPr lang="en-GB" sz="1800" b="0" strike="noStrike" spc="-1" dirty="0">
+                <a:solidFill>
+                  <a:srgbClr val="0073CF"/>
+                </a:solidFill>
+                <a:latin typeface="Arial"/>
+              </a:rPr>
+              <a:t>Wilcoxon</a:t>
+            </a:r>
+            <a:r>
+              <a:rPr lang="en-GB" sz="1800" b="0" strike="noStrike" spc="-1" dirty="0">
+                <a:solidFill>
+                  <a:srgbClr val="203232"/>
+                </a:solidFill>
+                <a:latin typeface="Arial"/>
+              </a:rPr>
+              <a:t> also known as the </a:t>
+            </a:r>
+            <a:r>
+              <a:rPr lang="en-GB" sz="1800" b="0" strike="noStrike" spc="-1" dirty="0">
+                <a:solidFill>
+                  <a:srgbClr val="0073CF"/>
+                </a:solidFill>
+                <a:latin typeface="Arial"/>
+              </a:rPr>
+              <a:t>Mann Whitney U Test.</a:t>
+            </a:r>
+            <a:endParaRPr lang="en-US" sz="1800" b="0" strike="noStrike" spc="-1" dirty="0">
+              <a:latin typeface="Arial"/>
+            </a:endParaRPr>
+          </a:p>
+          <a:p>
+            <a:pPr>
+              <a:lnSpc>
+                <a:spcPct val="100000"/>
+              </a:lnSpc>
+            </a:pPr>
+            <a:endParaRPr lang="en-US" sz="1800" b="0" strike="noStrike" spc="-1">
+              <a:latin typeface="Arial"/>
+            </a:endParaRPr>
+          </a:p>
+          <a:p>
+            <a:pPr>
+              <a:lnSpc>
+                <a:spcPct val="100000"/>
+              </a:lnSpc>
+            </a:pPr>
+            <a:r>
+              <a:rPr lang="en-GB" sz="1800" b="0" strike="noStrike" spc="-1" dirty="0">
+                <a:solidFill>
+                  <a:srgbClr val="0073CF"/>
+                </a:solidFill>
+                <a:latin typeface="Arial"/>
+              </a:rPr>
+              <a:t>The example here is borderline, in terms of shape, so when in doubt choose the non-parametric equivalent.</a:t>
+            </a:r>
+            <a:endParaRPr lang="en-US" sz="1800" b="0" strike="noStrike" spc="-1" dirty="0">
+              <a:latin typeface="Arial"/>
+            </a:endParaRPr>
+          </a:p>
+          <a:p>
+            <a:pPr>
+              <a:lnSpc>
+                <a:spcPct val="100000"/>
+              </a:lnSpc>
+            </a:pPr>
+            <a:endParaRPr lang="en-US" sz="1800" b="0" strike="noStrike" spc="-1">
+              <a:latin typeface="Arial"/>
+            </a:endParaRPr>
+          </a:p>
+        </p:txBody>
+      </p:sp>
+      <p:pic>
+        <p:nvPicPr>
+          <p:cNvPr id="6" name="Picture 5" descr="A graph with a red line&#10;&#10;AI-generated content may be incorrect.">
+            <a:extLst>
+              <a:ext uri="{FF2B5EF4-FFF2-40B4-BE49-F238E27FC236}">
+                <a16:creationId xmlns:a16="http://schemas.microsoft.com/office/drawing/2014/main" id="{AF070A4E-4B78-BDFB-3318-A3766DC253A5}"/>
+              </a:ext>
+            </a:extLst>
+          </p:cNvPr>
+          <p:cNvPicPr>
+            <a:picLocks noChangeAspect="1"/>
+          </p:cNvPicPr>
+          <p:nvPr/>
+        </p:nvPicPr>
+        <p:blipFill>
+          <a:blip r:embed="rId2"/>
+          <a:stretch>
+            <a:fillRect/>
+          </a:stretch>
+        </p:blipFill>
+        <p:spPr>
+          <a:xfrm>
+            <a:off x="1341070" y="1639214"/>
+            <a:ext cx="4102795" cy="4873929"/>
+          </a:xfrm>
+          <a:prstGeom prst="rect">
+            <a:avLst/>
+          </a:prstGeom>
+        </p:spPr>
+      </p:pic>
+    </p:spTree>
+    <p:extLst>
+      <p:ext uri="{BB962C8B-B14F-4D97-AF65-F5344CB8AC3E}">
+        <p14:creationId xmlns:p14="http://schemas.microsoft.com/office/powerpoint/2010/main" val="3345483288"/>
+      </p:ext>
+    </p:extLst>
+  </p:cSld>
+  <p:clrMapOvr>
+    <a:masterClrMapping/>
+  </p:clrMapOvr>
+</p:sld>
+</file>
+
+<file path=ppt/slides/slide6.xml><?xml version="1.0" encoding="utf-8"?>
+<p:sld xmlns:a="http://schemas.openxmlformats.org/drawingml/2006/main" xmlns:r="http://schemas.openxmlformats.org/officeDocument/2006/relationships" xmlns:p="http://schemas.openxmlformats.org/presentationml/2006/main">
+  <p:cSld>
+    <p:spTree>
+      <p:nvGrpSpPr>
+        <p:cNvPr id="1" name="">
+          <a:extLst>
+            <a:ext uri="{FF2B5EF4-FFF2-40B4-BE49-F238E27FC236}">
+              <a16:creationId xmlns:a16="http://schemas.microsoft.com/office/drawing/2014/main" id="{B9FC974F-1962-2D4A-FD4C-2E0A30447104}"/>
+            </a:ext>
+          </a:extLst>
+        </p:cNvPr>
+        <p:cNvGrpSpPr/>
+        <p:nvPr/>
+      </p:nvGrpSpPr>
+      <p:grpSpPr>
+        <a:xfrm>
+          <a:off x="0" y="0"/>
+          <a:ext cx="0" cy="0"/>
+          <a:chOff x="0" y="0"/>
+          <a:chExt cx="0" cy="0"/>
+        </a:xfrm>
+      </p:grpSpPr>
+      <p:sp>
+        <p:nvSpPr>
+          <p:cNvPr id="4" name="Slide Number Placeholder 3">
+            <a:extLst>
+              <a:ext uri="{FF2B5EF4-FFF2-40B4-BE49-F238E27FC236}">
+                <a16:creationId xmlns:a16="http://schemas.microsoft.com/office/drawing/2014/main" id="{F4B5B557-7B8F-B5B4-3352-EF8CDA971C2B}"/>
+              </a:ext>
+            </a:extLst>
+          </p:cNvPr>
+          <p:cNvSpPr>
+            <a:spLocks noGrp="1"/>
+          </p:cNvSpPr>
+          <p:nvPr>
+            <p:ph type="sldNum" idx="12"/>
+          </p:nvPr>
+        </p:nvSpPr>
+        <p:spPr/>
+        <p:txBody>
+          <a:bodyPr/>
+          <a:lstStyle/>
+          <a:p>
+            <a:pPr marL="0" lvl="0" indent="0" algn="r" rtl="0">
+              <a:spcBef>
+                <a:spcPts val="0"/>
+              </a:spcBef>
+              <a:spcAft>
+                <a:spcPts val="0"/>
+              </a:spcAft>
+              <a:buNone/>
+            </a:pPr>
+            <a:fld id="{00000000-1234-1234-1234-123412341234}" type="slidenum">
+              <a:rPr lang="en-GB" smtClean="0"/>
+              <a:pPr marL="0" lvl="0" indent="0" algn="r" rtl="0">
+                <a:spcBef>
+                  <a:spcPts val="0"/>
+                </a:spcBef>
+                <a:spcAft>
+                  <a:spcPts val="0"/>
+                </a:spcAft>
+                <a:buNone/>
+              </a:pPr>
+              <a:t>6</a:t>
+            </a:fld>
+            <a:endParaRPr lang="en-GB"/>
+          </a:p>
+        </p:txBody>
+      </p:sp>
+      <p:sp>
+        <p:nvSpPr>
+          <p:cNvPr id="8" name="Title 1">
+            <a:extLst>
+              <a:ext uri="{FF2B5EF4-FFF2-40B4-BE49-F238E27FC236}">
+                <a16:creationId xmlns:a16="http://schemas.microsoft.com/office/drawing/2014/main" id="{43C1A096-E131-E8CF-6081-EEC0BBA8D09B}"/>
+              </a:ext>
+            </a:extLst>
+          </p:cNvPr>
+          <p:cNvSpPr txBox="1">
+            <a:spLocks/>
+          </p:cNvSpPr>
+          <p:nvPr/>
+        </p:nvSpPr>
+        <p:spPr>
+          <a:xfrm>
+            <a:off x="852952" y="569974"/>
+            <a:ext cx="10112417" cy="886907"/>
+          </a:xfrm>
+          <a:prstGeom prst="rect">
+            <a:avLst/>
+          </a:prstGeom>
+          <a:noFill/>
+          <a:ln>
+            <a:noFill/>
+          </a:ln>
+        </p:spPr>
+        <p:txBody>
+          <a:bodyPr spcFirstLastPara="1" wrap="square" lIns="0" tIns="0" rIns="0" bIns="0" anchor="t" anchorCtr="0">
+            <a:noAutofit/>
+          </a:bodyPr>
+          <a:lstStyle>
+            <a:defPPr marR="0" lvl="0" algn="l" rtl="0">
+              <a:lnSpc>
+                <a:spcPct val="100000"/>
+              </a:lnSpc>
+              <a:spcBef>
+                <a:spcPts val="0"/>
+              </a:spcBef>
+              <a:spcAft>
+                <a:spcPts val="0"/>
+              </a:spcAft>
+            </a:defPPr>
+            <a:lvl1pPr marR="0" lvl="0" algn="l" rtl="0">
+              <a:lnSpc>
+                <a:spcPct val="200000"/>
+              </a:lnSpc>
+              <a:spcBef>
+                <a:spcPts val="0"/>
+              </a:spcBef>
+              <a:spcAft>
+                <a:spcPts val="0"/>
+              </a:spcAft>
+              <a:buClr>
+                <a:srgbClr val="203232"/>
+              </a:buClr>
+              <a:buSzPts val="1800"/>
+              <a:buFont typeface="Arial"/>
+              <a:buNone/>
+              <a:defRPr sz="3600" b="1" i="0" u="none" strike="noStrike" cap="none">
+                <a:solidFill>
+                  <a:srgbClr val="203232"/>
+                </a:solidFill>
+                <a:latin typeface="Arial"/>
+                <a:ea typeface="Arial"/>
+                <a:cs typeface="Arial"/>
+                <a:sym typeface="Arial"/>
+              </a:defRPr>
+            </a:lvl1pPr>
+            <a:lvl2pPr marR="0" lvl="1" algn="l" rtl="0">
+              <a:lnSpc>
+                <a:spcPct val="100000"/>
+              </a:lnSpc>
+              <a:spcBef>
+                <a:spcPts val="0"/>
+              </a:spcBef>
+              <a:spcAft>
+                <a:spcPts val="0"/>
+              </a:spcAft>
+              <a:buClr>
+                <a:srgbClr val="000000"/>
+              </a:buClr>
+              <a:buSzPts val="1400"/>
+              <a:buFont typeface="Arial"/>
+              <a:buNone/>
+              <a:defRPr sz="1800" b="0" i="0" u="none" strike="noStrike" cap="none">
+                <a:solidFill>
+                  <a:srgbClr val="000000"/>
+                </a:solidFill>
+                <a:latin typeface="Arial"/>
+                <a:ea typeface="Arial"/>
+                <a:cs typeface="Arial"/>
+                <a:sym typeface="Arial"/>
+              </a:defRPr>
+            </a:lvl2pPr>
+            <a:lvl3pPr marR="0" lvl="2" algn="l" rtl="0">
+              <a:lnSpc>
+                <a:spcPct val="100000"/>
+              </a:lnSpc>
+              <a:spcBef>
+                <a:spcPts val="0"/>
+              </a:spcBef>
+              <a:spcAft>
+                <a:spcPts val="0"/>
+              </a:spcAft>
+              <a:buClr>
+                <a:srgbClr val="000000"/>
+              </a:buClr>
+              <a:buSzPts val="1400"/>
+              <a:buFont typeface="Arial"/>
+              <a:buNone/>
+              <a:defRPr sz="1800" b="0" i="0" u="none" strike="noStrike" cap="none">
+                <a:solidFill>
+                  <a:srgbClr val="000000"/>
+                </a:solidFill>
+                <a:latin typeface="Arial"/>
+                <a:ea typeface="Arial"/>
+                <a:cs typeface="Arial"/>
+                <a:sym typeface="Arial"/>
+              </a:defRPr>
+            </a:lvl3pPr>
+            <a:lvl4pPr marR="0" lvl="3" algn="l" rtl="0">
+              <a:lnSpc>
+                <a:spcPct val="100000"/>
+              </a:lnSpc>
+              <a:spcBef>
+                <a:spcPts val="0"/>
+              </a:spcBef>
+              <a:spcAft>
+                <a:spcPts val="0"/>
+              </a:spcAft>
+              <a:buClr>
+                <a:srgbClr val="000000"/>
+              </a:buClr>
+              <a:buSzPts val="1400"/>
+              <a:buFont typeface="Arial"/>
+              <a:buNone/>
+              <a:defRPr sz="1800" b="0" i="0" u="none" strike="noStrike" cap="none">
+                <a:solidFill>
+                  <a:srgbClr val="000000"/>
+                </a:solidFill>
+                <a:latin typeface="Arial"/>
+                <a:ea typeface="Arial"/>
+                <a:cs typeface="Arial"/>
+                <a:sym typeface="Arial"/>
+              </a:defRPr>
+            </a:lvl4pPr>
+            <a:lvl5pPr marR="0" lvl="4" algn="l" rtl="0">
+              <a:lnSpc>
+                <a:spcPct val="100000"/>
+              </a:lnSpc>
+              <a:spcBef>
+                <a:spcPts val="0"/>
+              </a:spcBef>
+              <a:spcAft>
+                <a:spcPts val="0"/>
+              </a:spcAft>
+              <a:buClr>
+                <a:srgbClr val="000000"/>
+              </a:buClr>
+              <a:buSzPts val="1400"/>
+              <a:buFont typeface="Arial"/>
+              <a:buNone/>
+              <a:defRPr sz="1800" b="0" i="0" u="none" strike="noStrike" cap="none">
+                <a:solidFill>
+                  <a:srgbClr val="000000"/>
+                </a:solidFill>
+                <a:latin typeface="Arial"/>
+                <a:ea typeface="Arial"/>
+                <a:cs typeface="Arial"/>
+                <a:sym typeface="Arial"/>
+              </a:defRPr>
+            </a:lvl5pPr>
+            <a:lvl6pPr marR="0" lvl="5" algn="l" rtl="0">
+              <a:lnSpc>
+                <a:spcPct val="100000"/>
+              </a:lnSpc>
+              <a:spcBef>
+                <a:spcPts val="0"/>
+              </a:spcBef>
+              <a:spcAft>
+                <a:spcPts val="0"/>
+              </a:spcAft>
+              <a:buClr>
+                <a:srgbClr val="000000"/>
+              </a:buClr>
+              <a:buSzPts val="1400"/>
+              <a:buFont typeface="Arial"/>
+              <a:buNone/>
+              <a:defRPr sz="1800" b="0" i="0" u="none" strike="noStrike" cap="none">
+                <a:solidFill>
+                  <a:srgbClr val="000000"/>
+                </a:solidFill>
+                <a:latin typeface="Arial"/>
+                <a:ea typeface="Arial"/>
+                <a:cs typeface="Arial"/>
+                <a:sym typeface="Arial"/>
+              </a:defRPr>
+            </a:lvl6pPr>
+            <a:lvl7pPr marR="0" lvl="6" algn="l" rtl="0">
+              <a:lnSpc>
+                <a:spcPct val="100000"/>
+              </a:lnSpc>
+              <a:spcBef>
+                <a:spcPts val="0"/>
+              </a:spcBef>
+              <a:spcAft>
+                <a:spcPts val="0"/>
+              </a:spcAft>
+              <a:buClr>
+                <a:srgbClr val="000000"/>
+              </a:buClr>
+              <a:buSzPts val="1400"/>
+              <a:buFont typeface="Arial"/>
+              <a:buNone/>
+              <a:defRPr sz="1800" b="0" i="0" u="none" strike="noStrike" cap="none">
+                <a:solidFill>
+                  <a:srgbClr val="000000"/>
+                </a:solidFill>
+                <a:latin typeface="Arial"/>
+                <a:ea typeface="Arial"/>
+                <a:cs typeface="Arial"/>
+                <a:sym typeface="Arial"/>
+              </a:defRPr>
+            </a:lvl7pPr>
+            <a:lvl8pPr marR="0" lvl="7" algn="l" rtl="0">
+              <a:lnSpc>
+                <a:spcPct val="100000"/>
+              </a:lnSpc>
+              <a:spcBef>
+                <a:spcPts val="0"/>
+              </a:spcBef>
+              <a:spcAft>
+                <a:spcPts val="0"/>
+              </a:spcAft>
+              <a:buClr>
+                <a:srgbClr val="000000"/>
+              </a:buClr>
+              <a:buSzPts val="1400"/>
+              <a:buFont typeface="Arial"/>
+              <a:buNone/>
+              <a:defRPr sz="1800" b="0" i="0" u="none" strike="noStrike" cap="none">
+                <a:solidFill>
+                  <a:srgbClr val="000000"/>
+                </a:solidFill>
+                <a:latin typeface="Arial"/>
+                <a:ea typeface="Arial"/>
+                <a:cs typeface="Arial"/>
+                <a:sym typeface="Arial"/>
+              </a:defRPr>
+            </a:lvl8pPr>
+            <a:lvl9pPr marR="0" lvl="8" algn="l" rtl="0">
+              <a:lnSpc>
+                <a:spcPct val="100000"/>
+              </a:lnSpc>
+              <a:spcBef>
+                <a:spcPts val="0"/>
+              </a:spcBef>
+              <a:spcAft>
+                <a:spcPts val="0"/>
+              </a:spcAft>
+              <a:buClr>
+                <a:srgbClr val="000000"/>
+              </a:buClr>
+              <a:buSzPts val="1400"/>
+              <a:buFont typeface="Arial"/>
+              <a:buNone/>
+              <a:defRPr sz="1800" b="0" i="0" u="none" strike="noStrike" cap="none">
+                <a:solidFill>
+                  <a:srgbClr val="000000"/>
+                </a:solidFill>
+                <a:latin typeface="Arial"/>
+                <a:ea typeface="Arial"/>
+                <a:cs typeface="Arial"/>
+                <a:sym typeface="Arial"/>
+              </a:defRPr>
+            </a:lvl9pPr>
+          </a:lstStyle>
+          <a:p>
+            <a:r>
+              <a:rPr lang="en-US" sz="3200" dirty="0"/>
+              <a:t>R Script and Results – The Analysis </a:t>
+            </a:r>
+            <a:endParaRPr lang="en-US"/>
+          </a:p>
+          <a:p>
+            <a:endParaRPr lang="en-US" sz="2800" dirty="0"/>
+          </a:p>
+          <a:p>
+            <a:endParaRPr lang="en-US" sz="2800" dirty="0"/>
+          </a:p>
+        </p:txBody>
+      </p:sp>
+      <p:sp>
+        <p:nvSpPr>
+          <p:cNvPr id="3" name="Google Shape;100;p17">
+            <a:extLst>
+              <a:ext uri="{FF2B5EF4-FFF2-40B4-BE49-F238E27FC236}">
+                <a16:creationId xmlns:a16="http://schemas.microsoft.com/office/drawing/2014/main" id="{384D506F-40ED-A99E-98F5-C47355A4FCE6}"/>
+              </a:ext>
+            </a:extLst>
+          </p:cNvPr>
+          <p:cNvSpPr txBox="1">
+            <a:spLocks noGrp="1"/>
+          </p:cNvSpPr>
+          <p:nvPr>
+            <p:ph type="ftr" idx="11"/>
+          </p:nvPr>
+        </p:nvSpPr>
+        <p:spPr>
+          <a:xfrm>
+            <a:off x="755462" y="548066"/>
+            <a:ext cx="10104598" cy="242037"/>
+          </a:xfrm>
+          <a:prstGeom prst="rect">
+            <a:avLst/>
+          </a:prstGeom>
+          <a:noFill/>
+          <a:ln>
+            <a:noFill/>
+          </a:ln>
+        </p:spPr>
+        <p:txBody>
+          <a:bodyPr spcFirstLastPara="1" wrap="square" lIns="0" tIns="0" rIns="0" bIns="0" anchor="t" anchorCtr="0">
+            <a:noAutofit/>
+          </a:bodyPr>
+          <a:lstStyle/>
+          <a:p>
+            <a:r>
+              <a:rPr lang="en-GB" dirty="0"/>
+              <a:t>7COM1079-2025  Student Group No:    A 104    Names of Student Group Attendees: All group members</a:t>
+            </a:r>
+            <a:endParaRPr dirty="0"/>
+          </a:p>
+        </p:txBody>
+      </p:sp>
+      <p:sp>
+        <p:nvSpPr>
+          <p:cNvPr id="5" name="TextBox 4">
+            <a:extLst>
+              <a:ext uri="{FF2B5EF4-FFF2-40B4-BE49-F238E27FC236}">
+                <a16:creationId xmlns:a16="http://schemas.microsoft.com/office/drawing/2014/main" id="{9DB9135B-77ED-809E-3646-B52EA6D874E0}"/>
+              </a:ext>
+            </a:extLst>
+          </p:cNvPr>
+          <p:cNvSpPr txBox="1"/>
+          <p:nvPr/>
+        </p:nvSpPr>
+        <p:spPr>
+          <a:xfrm>
+            <a:off x="753650" y="1452457"/>
+            <a:ext cx="11066988" cy="5139869"/>
+          </a:xfrm>
+          <a:prstGeom prst="rect">
+            <a:avLst/>
+          </a:prstGeom>
+          <a:solidFill>
+            <a:schemeClr val="bg1"/>
+          </a:solidFill>
+        </p:spPr>
+        <p:txBody>
+          <a:bodyPr wrap="square" lIns="91440" tIns="45720" rIns="91440" bIns="45720" rtlCol="0" anchor="t">
+            <a:spAutoFit/>
+          </a:bodyPr>
+          <a:lstStyle/>
+          <a:p>
+            <a:r>
+              <a:rPr lang="en-US" sz="2800" strike="noStrike" spc="-202" dirty="0">
+                <a:solidFill>
+                  <a:schemeClr val="accent1">
+                    <a:lumMod val="76000"/>
+                  </a:schemeClr>
+                </a:solidFill>
+                <a:latin typeface="Arial"/>
+              </a:rPr>
+              <a:t>Include a snippet of the R code you </a:t>
+            </a:r>
+            <a:r>
+              <a:rPr lang="en-US" sz="2800" spc="-202" dirty="0">
+                <a:solidFill>
+                  <a:schemeClr val="accent1">
+                    <a:lumMod val="76000"/>
+                  </a:schemeClr>
+                </a:solidFill>
+              </a:rPr>
+              <a:t>used</a:t>
+            </a:r>
+            <a:r>
+              <a:rPr lang="en-US" sz="2800" strike="noStrike" spc="-202" dirty="0">
+                <a:solidFill>
+                  <a:schemeClr val="accent1">
+                    <a:lumMod val="76000"/>
+                  </a:schemeClr>
+                </a:solidFill>
+                <a:latin typeface="Arial"/>
+              </a:rPr>
+              <a:t> to calculate your test statistic.</a:t>
+            </a:r>
+            <a:endParaRPr lang="en-US" sz="2800" dirty="0">
+              <a:solidFill>
+                <a:schemeClr val="accent1">
+                  <a:lumMod val="76000"/>
+                </a:schemeClr>
+              </a:solidFill>
+            </a:endParaRPr>
+          </a:p>
+          <a:p>
+            <a:endParaRPr lang="en-US" sz="2800" spc="-202" dirty="0">
+              <a:solidFill>
+                <a:schemeClr val="accent1">
+                  <a:lumMod val="76000"/>
+                </a:schemeClr>
+              </a:solidFill>
+            </a:endParaRPr>
+          </a:p>
+          <a:p>
+            <a:r>
+              <a:rPr lang="en-US" sz="2400" spc="-202" dirty="0">
+                <a:solidFill>
+                  <a:schemeClr val="tx1"/>
+                </a:solidFill>
+                <a:latin typeface="Consolas"/>
+              </a:rPr>
+              <a:t>subset_df &lt;- subset(df, Occupation == "Doctor" | Occupation == "Engineer")</a:t>
+            </a:r>
+            <a:endParaRPr lang="en-US" sz="2400">
+              <a:solidFill>
+                <a:schemeClr val="tx1"/>
+              </a:solidFill>
+              <a:latin typeface="Consolas"/>
+            </a:endParaRPr>
+          </a:p>
+          <a:p>
+            <a:r>
+              <a:rPr lang="en-US" sz="2400" spc="-202" err="1">
+                <a:solidFill>
+                  <a:schemeClr val="tx1"/>
+                </a:solidFill>
+                <a:latin typeface="Consolas"/>
+              </a:rPr>
+              <a:t>colnames</a:t>
+            </a:r>
+            <a:r>
+              <a:rPr lang="en-US" sz="2400" spc="-202" dirty="0">
+                <a:solidFill>
+                  <a:schemeClr val="tx1"/>
+                </a:solidFill>
+                <a:latin typeface="Consolas"/>
+              </a:rPr>
+              <a:t>(</a:t>
+            </a:r>
+            <a:r>
+              <a:rPr lang="en-US" sz="2400" spc="-202" err="1">
+                <a:solidFill>
+                  <a:schemeClr val="tx1"/>
+                </a:solidFill>
+                <a:latin typeface="Consolas"/>
+              </a:rPr>
+              <a:t>subset_df</a:t>
+            </a:r>
+            <a:r>
+              <a:rPr lang="en-US" sz="2400" spc="-202" dirty="0">
+                <a:solidFill>
+                  <a:schemeClr val="tx1"/>
+                </a:solidFill>
+                <a:latin typeface="Consolas"/>
+              </a:rPr>
+              <a:t>)[8]&lt;- "Stress"</a:t>
+            </a:r>
+            <a:endParaRPr lang="en-US" sz="2400">
+              <a:solidFill>
+                <a:schemeClr val="tx1"/>
+              </a:solidFill>
+              <a:latin typeface="Consolas"/>
+            </a:endParaRPr>
+          </a:p>
+          <a:p>
+            <a:r>
+              <a:rPr lang="en-US" sz="2400" spc="-202" dirty="0">
+                <a:solidFill>
+                  <a:schemeClr val="tx1"/>
+                </a:solidFill>
+                <a:latin typeface="Consolas"/>
+              </a:rPr>
+              <a:t>wilcox.test(Stress ~ Occupation, data=subset_df)</a:t>
+            </a:r>
+            <a:endParaRPr lang="en-US" sz="2400">
+              <a:solidFill>
+                <a:schemeClr val="tx1"/>
+              </a:solidFill>
+              <a:latin typeface="Consolas"/>
+            </a:endParaRPr>
+          </a:p>
+          <a:p>
+            <a:endParaRPr lang="en-US" sz="2400" spc="-202" dirty="0">
+              <a:solidFill>
+                <a:srgbClr val="203232"/>
+              </a:solidFill>
+              <a:latin typeface="Consolas"/>
+            </a:endParaRPr>
+          </a:p>
+          <a:p>
+            <a:r>
+              <a:rPr lang="en-US" sz="2800" strike="noStrike" spc="-202" dirty="0">
+                <a:solidFill>
+                  <a:schemeClr val="accent1">
+                    <a:lumMod val="76000"/>
+                  </a:schemeClr>
+                </a:solidFill>
+                <a:latin typeface="Arial"/>
+              </a:rPr>
+              <a:t>Give the value of the test statistic.</a:t>
+            </a:r>
+            <a:r>
+              <a:rPr lang="en-US" sz="2800" spc="-202" dirty="0">
+                <a:solidFill>
+                  <a:schemeClr val="accent1">
+                    <a:lumMod val="76000"/>
+                  </a:schemeClr>
+                </a:solidFill>
+              </a:rPr>
+              <a:t> </a:t>
+            </a:r>
+            <a:endParaRPr lang="en-US" sz="2800">
+              <a:solidFill>
+                <a:schemeClr val="accent1">
+                  <a:lumMod val="76000"/>
+                </a:schemeClr>
+              </a:solidFill>
+              <a:latin typeface="Consolas"/>
+            </a:endParaRPr>
+          </a:p>
+          <a:p>
+            <a:r>
+              <a:rPr lang="en-US" sz="2800" spc="-202" dirty="0">
+                <a:solidFill>
+                  <a:schemeClr val="tx1"/>
+                </a:solidFill>
+                <a:latin typeface="Consolas"/>
+              </a:rPr>
+              <a:t>W = 4153, p-value &lt; 2.2e-16 </a:t>
+            </a:r>
+          </a:p>
+          <a:p>
+            <a:r>
+              <a:rPr lang="en-US" sz="2800" spc="-202" dirty="0">
+                <a:solidFill>
+                  <a:schemeClr val="tx1"/>
+                </a:solidFill>
+                <a:latin typeface="Consolas"/>
+              </a:rPr>
+              <a:t>p-value is less than 0.05</a:t>
+            </a:r>
+            <a:endParaRPr lang="en-US" sz="2800">
+              <a:solidFill>
+                <a:schemeClr val="tx1"/>
+              </a:solidFill>
+              <a:latin typeface="Consolas"/>
+            </a:endParaRPr>
+          </a:p>
+          <a:p>
+            <a:endParaRPr lang="en-US" sz="3200" strike="noStrike" spc="-202" dirty="0">
+              <a:solidFill>
+                <a:srgbClr val="203232"/>
+              </a:solidFill>
+              <a:latin typeface="Arial"/>
+            </a:endParaRPr>
+          </a:p>
+          <a:p>
+            <a:r>
+              <a:rPr lang="en-US" sz="3200" strike="noStrike" spc="-202" dirty="0">
+                <a:solidFill>
+                  <a:srgbClr val="203232"/>
+                </a:solidFill>
+                <a:latin typeface="Arial"/>
+              </a:rPr>
+              <a:t> </a:t>
+            </a:r>
+            <a:r>
+              <a:rPr lang="en-US" sz="2800" strike="noStrike" spc="-202" dirty="0">
+                <a:solidFill>
+                  <a:schemeClr val="accent1">
+                    <a:lumMod val="76000"/>
+                  </a:schemeClr>
+                </a:solidFill>
+                <a:latin typeface="Arial"/>
+              </a:rPr>
+              <a:t>Is the result significant?</a:t>
+            </a:r>
+          </a:p>
+          <a:p>
+            <a:r>
+              <a:rPr lang="en-US" sz="2800" spc="-202" dirty="0">
+                <a:solidFill>
+                  <a:schemeClr val="tx1"/>
+                </a:solidFill>
+                <a:latin typeface="Consolas"/>
+              </a:rPr>
+              <a:t>Yes, the result is significant.</a:t>
+            </a:r>
+            <a:endParaRPr lang="en-US" sz="2800" dirty="0">
+              <a:solidFill>
+                <a:schemeClr val="tx1"/>
+              </a:solidFill>
+            </a:endParaRPr>
+          </a:p>
+        </p:txBody>
+      </p:sp>
+    </p:spTree>
+    <p:extLst>
+      <p:ext uri="{BB962C8B-B14F-4D97-AF65-F5344CB8AC3E}">
+        <p14:creationId xmlns:p14="http://schemas.microsoft.com/office/powerpoint/2010/main" val="3022571736"/>
+      </p:ext>
+    </p:extLst>
+  </p:cSld>
+  <p:clrMapOvr>
+    <a:masterClrMapping/>
+  </p:clrMapOvr>
+</p:sld>
+</file>
+
+<file path=ppt/slides/slide7.xml><?xml version="1.0" encoding="utf-8"?>
+<p:sld xmlns:a="http://schemas.openxmlformats.org/drawingml/2006/main" xmlns:r="http://schemas.openxmlformats.org/officeDocument/2006/relationships" xmlns:p="http://schemas.openxmlformats.org/presentationml/2006/main">
+  <p:cSld>
+    <p:spTree>
+      <p:nvGrpSpPr>
+        <p:cNvPr id="1" name="">
+          <a:extLst>
+            <a:ext uri="{FF2B5EF4-FFF2-40B4-BE49-F238E27FC236}">
+              <a16:creationId xmlns:a16="http://schemas.microsoft.com/office/drawing/2014/main" id="{1AE5B34A-60A2-E58D-DAA9-03AF9825B9D8}"/>
+            </a:ext>
+          </a:extLst>
+        </p:cNvPr>
+        <p:cNvGrpSpPr/>
+        <p:nvPr/>
+      </p:nvGrpSpPr>
+      <p:grpSpPr>
+        <a:xfrm>
+          <a:off x="0" y="0"/>
+          <a:ext cx="0" cy="0"/>
+          <a:chOff x="0" y="0"/>
+          <a:chExt cx="0" cy="0"/>
+        </a:xfrm>
+      </p:grpSpPr>
+      <p:sp>
+        <p:nvSpPr>
+          <p:cNvPr id="4" name="Slide Number Placeholder 3">
+            <a:extLst>
+              <a:ext uri="{FF2B5EF4-FFF2-40B4-BE49-F238E27FC236}">
+                <a16:creationId xmlns:a16="http://schemas.microsoft.com/office/drawing/2014/main" id="{76915462-772E-384B-2697-A702F83BBFD0}"/>
+              </a:ext>
+            </a:extLst>
+          </p:cNvPr>
+          <p:cNvSpPr>
+            <a:spLocks noGrp="1"/>
+          </p:cNvSpPr>
+          <p:nvPr>
+            <p:ph type="sldNum" idx="12"/>
+          </p:nvPr>
+        </p:nvSpPr>
+        <p:spPr/>
+        <p:txBody>
+          <a:bodyPr/>
+          <a:lstStyle/>
+          <a:p>
+            <a:pPr marL="0" lvl="0" indent="0" algn="r" rtl="0">
+              <a:spcBef>
+                <a:spcPts val="0"/>
+              </a:spcBef>
+              <a:spcAft>
+                <a:spcPts val="0"/>
+              </a:spcAft>
+              <a:buNone/>
+            </a:pPr>
+            <a:fld id="{00000000-1234-1234-1234-123412341234}" type="slidenum">
+              <a:rPr lang="en-GB" smtClean="0"/>
+              <a:pPr marL="0" lvl="0" indent="0" algn="r" rtl="0">
+                <a:spcBef>
+                  <a:spcPts val="0"/>
+                </a:spcBef>
+                <a:spcAft>
+                  <a:spcPts val="0"/>
+                </a:spcAft>
+                <a:buNone/>
+              </a:pPr>
+              <a:t>7</a:t>
+            </a:fld>
+            <a:endParaRPr lang="en-GB"/>
+          </a:p>
+        </p:txBody>
+      </p:sp>
+      <p:sp>
+        <p:nvSpPr>
+          <p:cNvPr id="3" name="Google Shape;100;p17">
+            <a:extLst>
+              <a:ext uri="{FF2B5EF4-FFF2-40B4-BE49-F238E27FC236}">
+                <a16:creationId xmlns:a16="http://schemas.microsoft.com/office/drawing/2014/main" id="{59A0393D-7C87-19FE-0476-B7570C22510F}"/>
+              </a:ext>
+            </a:extLst>
+          </p:cNvPr>
+          <p:cNvSpPr txBox="1">
+            <a:spLocks noGrp="1"/>
+          </p:cNvSpPr>
+          <p:nvPr>
+            <p:ph type="ftr" idx="11"/>
+          </p:nvPr>
+        </p:nvSpPr>
+        <p:spPr>
+          <a:xfrm>
+            <a:off x="755462" y="548066"/>
+            <a:ext cx="10104598" cy="242037"/>
+          </a:xfrm>
+          <a:prstGeom prst="rect">
+            <a:avLst/>
+          </a:prstGeom>
+          <a:noFill/>
+          <a:ln>
+            <a:noFill/>
+          </a:ln>
+        </p:spPr>
+        <p:txBody>
+          <a:bodyPr spcFirstLastPara="1" wrap="square" lIns="0" tIns="0" rIns="0" bIns="0" anchor="t" anchorCtr="0">
+            <a:noAutofit/>
+          </a:bodyPr>
+          <a:lstStyle/>
+          <a:p>
+            <a:r>
+              <a:rPr lang="en-GB" dirty="0"/>
+              <a:t>7COM1079-2025  Student Group No:    A 104    Names of Student Group Attendees: All group members</a:t>
+            </a:r>
+            <a:endParaRPr dirty="0"/>
+          </a:p>
+        </p:txBody>
+      </p:sp>
+      <p:sp>
+        <p:nvSpPr>
+          <p:cNvPr id="5" name="TextBox 4">
+            <a:extLst>
+              <a:ext uri="{FF2B5EF4-FFF2-40B4-BE49-F238E27FC236}">
+                <a16:creationId xmlns:a16="http://schemas.microsoft.com/office/drawing/2014/main" id="{A14A084E-EEE6-FABE-FE4C-9A55D5E039F7}"/>
+              </a:ext>
+            </a:extLst>
+          </p:cNvPr>
+          <p:cNvSpPr txBox="1"/>
+          <p:nvPr/>
+        </p:nvSpPr>
+        <p:spPr>
+          <a:xfrm>
+            <a:off x="757487" y="1458752"/>
+            <a:ext cx="11066988" cy="5324535"/>
+          </a:xfrm>
+          <a:prstGeom prst="rect">
+            <a:avLst/>
+          </a:prstGeom>
+          <a:solidFill>
+            <a:schemeClr val="bg1"/>
+          </a:solidFill>
+        </p:spPr>
+        <p:txBody>
+          <a:bodyPr wrap="square" lIns="91440" tIns="45720" rIns="91440" bIns="45720" rtlCol="0" anchor="t">
+            <a:spAutoFit/>
+          </a:bodyPr>
+          <a:lstStyle/>
+          <a:p>
+            <a:r>
+              <a:rPr lang="en-US" sz="2800" strike="noStrike" spc="-202" dirty="0">
+                <a:solidFill>
+                  <a:schemeClr val="accent1">
+                    <a:lumMod val="76000"/>
+                  </a:schemeClr>
+                </a:solidFill>
+                <a:latin typeface="Arial"/>
+              </a:rPr>
+              <a:t>Do you ‘</a:t>
+            </a:r>
+            <a:r>
+              <a:rPr lang="en-US" sz="2800" spc="-202" dirty="0">
+                <a:solidFill>
+                  <a:schemeClr val="accent1">
+                    <a:lumMod val="76000"/>
+                  </a:schemeClr>
+                </a:solidFill>
+                <a:latin typeface="Arial"/>
+              </a:rPr>
+              <a:t>fail to reject the null hypothesis’</a:t>
+            </a:r>
+            <a:r>
+              <a:rPr lang="en-US" sz="2800" strike="noStrike" spc="-202" dirty="0">
+                <a:solidFill>
+                  <a:schemeClr val="accent1">
+                    <a:lumMod val="76000"/>
+                  </a:schemeClr>
+                </a:solidFill>
+                <a:latin typeface="Arial"/>
+              </a:rPr>
+              <a:t> or ‘reject the null hypothesis’?</a:t>
+            </a:r>
+            <a:endParaRPr lang="en-US" sz="2800" spc="-202" dirty="0">
+              <a:solidFill>
+                <a:schemeClr val="accent1">
+                  <a:lumMod val="76000"/>
+                </a:schemeClr>
+              </a:solidFill>
+            </a:endParaRPr>
+          </a:p>
+          <a:p>
+            <a:r>
+              <a:rPr lang="en-US" sz="2800" spc="-202" dirty="0">
+                <a:solidFill>
+                  <a:schemeClr val="tx1"/>
+                </a:solidFill>
+                <a:latin typeface="Consolas"/>
+              </a:rPr>
+              <a:t>There is a difference in the median stress level between doctors and engineers, so we reject the null hypothesis.</a:t>
+            </a:r>
+          </a:p>
+          <a:p>
+            <a:endParaRPr lang="en-US" sz="3200" spc="-202" dirty="0">
+              <a:solidFill>
+                <a:schemeClr val="accent1">
+                  <a:lumMod val="76000"/>
+                </a:schemeClr>
+              </a:solidFill>
+            </a:endParaRPr>
+          </a:p>
+          <a:p>
+            <a:r>
+              <a:rPr lang="en-US" sz="2800" spc="-202" dirty="0">
+                <a:solidFill>
+                  <a:schemeClr val="accent1">
+                    <a:lumMod val="76000"/>
+                  </a:schemeClr>
+                </a:solidFill>
+                <a:latin typeface="Arial"/>
+              </a:rPr>
+              <a:t>What does the result actually mean in the wider context of learning something useful / answering your RQ?</a:t>
+            </a:r>
+          </a:p>
+          <a:p>
+            <a:r>
+              <a:rPr lang="en-US" sz="2800" spc="-202" dirty="0">
+                <a:solidFill>
+                  <a:schemeClr val="tx1"/>
+                </a:solidFill>
+                <a:latin typeface="Consolas"/>
+              </a:rPr>
+              <a:t>Doctors and engineers in the 27 to 59 age group do not face the same stress levels. The difference is statistically significant, with doctors facing higher stress levels. Doctors bear the responsibility of decisions that affect human lives and often need to be ready for emergencies whereas engineers rarely face high pressure life-or-death situations.</a:t>
+            </a:r>
+          </a:p>
+        </p:txBody>
+      </p:sp>
+      <p:sp>
+        <p:nvSpPr>
+          <p:cNvPr id="6" name="Title 1">
+            <a:extLst>
+              <a:ext uri="{FF2B5EF4-FFF2-40B4-BE49-F238E27FC236}">
+                <a16:creationId xmlns:a16="http://schemas.microsoft.com/office/drawing/2014/main" id="{E2EEDBBF-9CF9-68DD-7476-CF0255C90267}"/>
+              </a:ext>
+            </a:extLst>
+          </p:cNvPr>
+          <p:cNvSpPr txBox="1">
+            <a:spLocks/>
+          </p:cNvSpPr>
+          <p:nvPr/>
+        </p:nvSpPr>
+        <p:spPr>
+          <a:xfrm>
+            <a:off x="852952" y="569974"/>
+            <a:ext cx="10112417" cy="886907"/>
+          </a:xfrm>
+          <a:prstGeom prst="rect">
+            <a:avLst/>
+          </a:prstGeom>
+          <a:noFill/>
+          <a:ln>
+            <a:noFill/>
+          </a:ln>
+        </p:spPr>
+        <p:txBody>
+          <a:bodyPr spcFirstLastPara="1" wrap="square" lIns="0" tIns="0" rIns="0" bIns="0" anchor="t" anchorCtr="0">
+            <a:noAutofit/>
+          </a:bodyPr>
+          <a:lstStyle>
+            <a:defPPr marR="0" lvl="0" algn="l" rtl="0">
+              <a:lnSpc>
+                <a:spcPct val="100000"/>
+              </a:lnSpc>
+              <a:spcBef>
+                <a:spcPts val="0"/>
+              </a:spcBef>
+              <a:spcAft>
+                <a:spcPts val="0"/>
+              </a:spcAft>
+            </a:defPPr>
+            <a:lvl1pPr marR="0" lvl="0" algn="l" rtl="0">
+              <a:lnSpc>
+                <a:spcPct val="200000"/>
+              </a:lnSpc>
+              <a:spcBef>
+                <a:spcPts val="0"/>
+              </a:spcBef>
+              <a:spcAft>
+                <a:spcPts val="0"/>
+              </a:spcAft>
+              <a:buClr>
+                <a:srgbClr val="203232"/>
+              </a:buClr>
+              <a:buSzPts val="1800"/>
+              <a:buFont typeface="Arial"/>
+              <a:buNone/>
+              <a:defRPr sz="3600" b="1" i="0" u="none" strike="noStrike" cap="none">
+                <a:solidFill>
+                  <a:srgbClr val="203232"/>
+                </a:solidFill>
+                <a:latin typeface="Arial"/>
+                <a:ea typeface="Arial"/>
+                <a:cs typeface="Arial"/>
+                <a:sym typeface="Arial"/>
+              </a:defRPr>
+            </a:lvl1pPr>
+            <a:lvl2pPr marR="0" lvl="1" algn="l" rtl="0">
+              <a:lnSpc>
+                <a:spcPct val="100000"/>
+              </a:lnSpc>
+              <a:spcBef>
+                <a:spcPts val="0"/>
+              </a:spcBef>
+              <a:spcAft>
+                <a:spcPts val="0"/>
+              </a:spcAft>
+              <a:buClr>
+                <a:srgbClr val="000000"/>
+              </a:buClr>
+              <a:buSzPts val="1400"/>
+              <a:buFont typeface="Arial"/>
+              <a:buNone/>
+              <a:defRPr sz="1800" b="0" i="0" u="none" strike="noStrike" cap="none">
+                <a:solidFill>
+                  <a:srgbClr val="000000"/>
+                </a:solidFill>
+                <a:latin typeface="Arial"/>
+                <a:ea typeface="Arial"/>
+                <a:cs typeface="Arial"/>
+                <a:sym typeface="Arial"/>
+              </a:defRPr>
+            </a:lvl2pPr>
+            <a:lvl3pPr marR="0" lvl="2" algn="l" rtl="0">
+              <a:lnSpc>
+                <a:spcPct val="100000"/>
+              </a:lnSpc>
+              <a:spcBef>
+                <a:spcPts val="0"/>
+              </a:spcBef>
+              <a:spcAft>
+                <a:spcPts val="0"/>
+              </a:spcAft>
+              <a:buClr>
+                <a:srgbClr val="000000"/>
+              </a:buClr>
+              <a:buSzPts val="1400"/>
+              <a:buFont typeface="Arial"/>
+              <a:buNone/>
+              <a:defRPr sz="1800" b="0" i="0" u="none" strike="noStrike" cap="none">
+                <a:solidFill>
+                  <a:srgbClr val="000000"/>
+                </a:solidFill>
+                <a:latin typeface="Arial"/>
+                <a:ea typeface="Arial"/>
+                <a:cs typeface="Arial"/>
+                <a:sym typeface="Arial"/>
+              </a:defRPr>
+            </a:lvl3pPr>
+            <a:lvl4pPr marR="0" lvl="3" algn="l" rtl="0">
+              <a:lnSpc>
+                <a:spcPct val="100000"/>
+              </a:lnSpc>
+              <a:spcBef>
+                <a:spcPts val="0"/>
+              </a:spcBef>
+              <a:spcAft>
+                <a:spcPts val="0"/>
+              </a:spcAft>
+              <a:buClr>
+                <a:srgbClr val="000000"/>
+              </a:buClr>
+              <a:buSzPts val="1400"/>
+              <a:buFont typeface="Arial"/>
+              <a:buNone/>
+              <a:defRPr sz="1800" b="0" i="0" u="none" strike="noStrike" cap="none">
+                <a:solidFill>
+                  <a:srgbClr val="000000"/>
+                </a:solidFill>
+                <a:latin typeface="Arial"/>
+                <a:ea typeface="Arial"/>
+                <a:cs typeface="Arial"/>
+                <a:sym typeface="Arial"/>
+              </a:defRPr>
+            </a:lvl4pPr>
+            <a:lvl5pPr marR="0" lvl="4" algn="l" rtl="0">
+              <a:lnSpc>
+                <a:spcPct val="100000"/>
+              </a:lnSpc>
+              <a:spcBef>
+                <a:spcPts val="0"/>
+              </a:spcBef>
+              <a:spcAft>
+                <a:spcPts val="0"/>
+              </a:spcAft>
+              <a:buClr>
+                <a:srgbClr val="000000"/>
+              </a:buClr>
+              <a:buSzPts val="1400"/>
+              <a:buFont typeface="Arial"/>
+              <a:buNone/>
+              <a:defRPr sz="1800" b="0" i="0" u="none" strike="noStrike" cap="none">
+                <a:solidFill>
+                  <a:srgbClr val="000000"/>
+                </a:solidFill>
+                <a:latin typeface="Arial"/>
+                <a:ea typeface="Arial"/>
+                <a:cs typeface="Arial"/>
+                <a:sym typeface="Arial"/>
+              </a:defRPr>
+            </a:lvl5pPr>
+            <a:lvl6pPr marR="0" lvl="5" algn="l" rtl="0">
+              <a:lnSpc>
+                <a:spcPct val="100000"/>
+              </a:lnSpc>
+              <a:spcBef>
+                <a:spcPts val="0"/>
+              </a:spcBef>
+              <a:spcAft>
+                <a:spcPts val="0"/>
+              </a:spcAft>
+              <a:buClr>
+                <a:srgbClr val="000000"/>
+              </a:buClr>
+              <a:buSzPts val="1400"/>
+              <a:buFont typeface="Arial"/>
+              <a:buNone/>
+              <a:defRPr sz="1800" b="0" i="0" u="none" strike="noStrike" cap="none">
+                <a:solidFill>
+                  <a:srgbClr val="000000"/>
+                </a:solidFill>
+                <a:latin typeface="Arial"/>
+                <a:ea typeface="Arial"/>
+                <a:cs typeface="Arial"/>
+                <a:sym typeface="Arial"/>
+              </a:defRPr>
+            </a:lvl6pPr>
+            <a:lvl7pPr marR="0" lvl="6" algn="l" rtl="0">
+              <a:lnSpc>
+                <a:spcPct val="100000"/>
+              </a:lnSpc>
+              <a:spcBef>
+                <a:spcPts val="0"/>
+              </a:spcBef>
+              <a:spcAft>
+                <a:spcPts val="0"/>
+              </a:spcAft>
+              <a:buClr>
+                <a:srgbClr val="000000"/>
+              </a:buClr>
+              <a:buSzPts val="1400"/>
+              <a:buFont typeface="Arial"/>
+              <a:buNone/>
+              <a:defRPr sz="1800" b="0" i="0" u="none" strike="noStrike" cap="none">
+                <a:solidFill>
+                  <a:srgbClr val="000000"/>
+                </a:solidFill>
+                <a:latin typeface="Arial"/>
+                <a:ea typeface="Arial"/>
+                <a:cs typeface="Arial"/>
+                <a:sym typeface="Arial"/>
+              </a:defRPr>
+            </a:lvl7pPr>
+            <a:lvl8pPr marR="0" lvl="7" algn="l" rtl="0">
+              <a:lnSpc>
+                <a:spcPct val="100000"/>
+              </a:lnSpc>
+              <a:spcBef>
+                <a:spcPts val="0"/>
+              </a:spcBef>
+              <a:spcAft>
+                <a:spcPts val="0"/>
+              </a:spcAft>
+              <a:buClr>
+                <a:srgbClr val="000000"/>
+              </a:buClr>
+              <a:buSzPts val="1400"/>
+              <a:buFont typeface="Arial"/>
+              <a:buNone/>
+              <a:defRPr sz="1800" b="0" i="0" u="none" strike="noStrike" cap="none">
+                <a:solidFill>
+                  <a:srgbClr val="000000"/>
+                </a:solidFill>
+                <a:latin typeface="Arial"/>
+                <a:ea typeface="Arial"/>
+                <a:cs typeface="Arial"/>
+                <a:sym typeface="Arial"/>
+              </a:defRPr>
+            </a:lvl8pPr>
+            <a:lvl9pPr marR="0" lvl="8" algn="l" rtl="0">
+              <a:lnSpc>
+                <a:spcPct val="100000"/>
+              </a:lnSpc>
+              <a:spcBef>
+                <a:spcPts val="0"/>
+              </a:spcBef>
+              <a:spcAft>
+                <a:spcPts val="0"/>
+              </a:spcAft>
+              <a:buClr>
+                <a:srgbClr val="000000"/>
+              </a:buClr>
+              <a:buSzPts val="1400"/>
+              <a:buFont typeface="Arial"/>
+              <a:buNone/>
+              <a:defRPr sz="1800" b="0" i="0" u="none" strike="noStrike" cap="none">
+                <a:solidFill>
+                  <a:srgbClr val="000000"/>
+                </a:solidFill>
+                <a:latin typeface="Arial"/>
+                <a:ea typeface="Arial"/>
+                <a:cs typeface="Arial"/>
+                <a:sym typeface="Arial"/>
+              </a:defRPr>
+            </a:lvl9pPr>
+          </a:lstStyle>
+          <a:p>
+            <a:r>
+              <a:rPr lang="en-US" sz="3200" dirty="0"/>
+              <a:t>R Script </a:t>
+            </a:r>
+            <a:r>
+              <a:rPr lang="en-US" sz="3200" dirty="0">
+                <a:solidFill>
+                  <a:schemeClr val="tx1"/>
+                </a:solidFill>
+              </a:rPr>
+              <a:t>and Results –</a:t>
+            </a:r>
+            <a:r>
+              <a:rPr lang="en-US" sz="3200" dirty="0"/>
+              <a:t> The Analysis </a:t>
+            </a:r>
+            <a:endParaRPr lang="en-US" dirty="0"/>
+          </a:p>
+        </p:txBody>
+      </p:sp>
+    </p:spTree>
+    <p:extLst>
+      <p:ext uri="{BB962C8B-B14F-4D97-AF65-F5344CB8AC3E}">
+        <p14:creationId xmlns:p14="http://schemas.microsoft.com/office/powerpoint/2010/main" val="274318596"/>
       </p:ext>
     </p:extLst>
   </p:cSld>

</xml_diff>

<commit_message>
Updated aspect ratio of curve graph
</commit_message>
<xml_diff>
--- a/demo_presentations/A104_Vis_and_Analysis_Presentation.pptx
+++ b/demo_presentations/A104_Vis_and_Analysis_Presentation.pptx
@@ -285,7 +285,7 @@
 <p1510:revInfo xmlns:a="http://schemas.openxmlformats.org/drawingml/2006/main" xmlns:r="http://schemas.openxmlformats.org/officeDocument/2006/relationships" xmlns:p1510="http://schemas.microsoft.com/office/powerpoint/2015/10/main">
   <p1510:revLst>
     <p1510:client id="{6D546167-77AF-D2AC-1A99-E07477C0F94B}" v="4" dt="2025-12-06T15:00:31.992"/>
-    <p1510:client id="{75EF905B-8216-F3C6-2E53-187A9D15709F}" v="228" dt="2025-12-08T13:38:01.308"/>
+    <p1510:client id="{75EF905B-8216-F3C6-2E53-187A9D15709F}" v="242" dt="2025-12-08T13:53:22.268"/>
   </p1510:revLst>
 </p1510:revInfo>
 </file>
@@ -14632,7 +14632,7 @@
         </p:nvSpPr>
         <p:spPr>
           <a:xfrm>
-            <a:off x="290880" y="1627560"/>
+            <a:off x="363949" y="1575368"/>
             <a:ext cx="10865160" cy="4886280"/>
           </a:xfrm>
           <a:prstGeom prst="roundRect">
@@ -14838,7 +14838,7 @@
         </p:nvSpPr>
         <p:spPr>
           <a:xfrm>
-            <a:off x="6682753" y="1999947"/>
+            <a:off x="6755822" y="2281783"/>
             <a:ext cx="4475760" cy="2860868"/>
           </a:xfrm>
           <a:prstGeom prst="rect">
@@ -14973,10 +14973,10 @@
       </p:sp>
       <p:pic>
         <p:nvPicPr>
-          <p:cNvPr id="6" name="Picture 5" descr="A graph with a red line&#10;&#10;AI-generated content may be incorrect.">
+          <p:cNvPr id="2" name="Picture 1">
             <a:extLst>
               <a:ext uri="{FF2B5EF4-FFF2-40B4-BE49-F238E27FC236}">
-                <a16:creationId xmlns:a16="http://schemas.microsoft.com/office/drawing/2014/main" id="{AF070A4E-4B78-BDFB-3318-A3766DC253A5}"/>
+                <a16:creationId xmlns:a16="http://schemas.microsoft.com/office/drawing/2014/main" id="{38D7AE82-C4AD-29CC-7DC5-5349EA2291B7}"/>
               </a:ext>
             </a:extLst>
           </p:cNvPr>
@@ -14993,8 +14993,8 @@
         </p:blipFill>
         <p:spPr>
           <a:xfrm>
-            <a:off x="1341070" y="1639214"/>
-            <a:ext cx="4102795" cy="4873929"/>
+            <a:off x="453478" y="2282738"/>
+            <a:ext cx="6097176" cy="3482499"/>
           </a:xfrm>
           <a:prstGeom prst="rect">
             <a:avLst/>

</xml_diff>

<commit_message>
Fixed y axis scale on curve
</commit_message>
<xml_diff>
--- a/demo_presentations/A104_Vis_and_Analysis_Presentation.pptx
+++ b/demo_presentations/A104_Vis_and_Analysis_Presentation.pptx
@@ -285,7 +285,7 @@
 <p1510:revInfo xmlns:a="http://schemas.openxmlformats.org/drawingml/2006/main" xmlns:r="http://schemas.openxmlformats.org/officeDocument/2006/relationships" xmlns:p1510="http://schemas.microsoft.com/office/powerpoint/2015/10/main">
   <p1510:revLst>
     <p1510:client id="{6D546167-77AF-D2AC-1A99-E07477C0F94B}" v="4" dt="2025-12-06T15:00:31.992"/>
-    <p1510:client id="{75EF905B-8216-F3C6-2E53-187A9D15709F}" v="242" dt="2025-12-08T13:53:22.268"/>
+    <p1510:client id="{75EF905B-8216-F3C6-2E53-187A9D15709F}" v="250" dt="2025-12-08T13:59:46.385"/>
   </p1510:revLst>
 </p1510:revInfo>
 </file>
@@ -14838,7 +14838,7 @@
         </p:nvSpPr>
         <p:spPr>
           <a:xfrm>
-            <a:off x="6755822" y="2281783"/>
+            <a:off x="6755822" y="2093893"/>
             <a:ext cx="4475760" cy="2860868"/>
           </a:xfrm>
           <a:prstGeom prst="rect">
@@ -14973,10 +14973,10 @@
       </p:sp>
       <p:pic>
         <p:nvPicPr>
-          <p:cNvPr id="2" name="Picture 1">
+          <p:cNvPr id="3" name="Picture 2" descr="A graph with a red line&#10;&#10;AI-generated content may be incorrect.">
             <a:extLst>
               <a:ext uri="{FF2B5EF4-FFF2-40B4-BE49-F238E27FC236}">
-                <a16:creationId xmlns:a16="http://schemas.microsoft.com/office/drawing/2014/main" id="{38D7AE82-C4AD-29CC-7DC5-5349EA2291B7}"/>
+                <a16:creationId xmlns:a16="http://schemas.microsoft.com/office/drawing/2014/main" id="{9887CAAA-5BA8-B082-09CA-C50C3F2EC57E}"/>
               </a:ext>
             </a:extLst>
           </p:cNvPr>
@@ -14993,8 +14993,8 @@
         </p:blipFill>
         <p:spPr>
           <a:xfrm>
-            <a:off x="453478" y="2282738"/>
-            <a:ext cx="6097176" cy="3482499"/>
+            <a:off x="578741" y="2091847"/>
+            <a:ext cx="5867531" cy="3853842"/>
           </a:xfrm>
           <a:prstGeom prst="rect">
             <a:avLst/>

</xml_diff>